<commit_message>
Fix text overflow in all slides - apply auto_size to fit containers
Set TEXT_TO_FIT_SHAPE on all 853 text frames across 3 PPTX files.
PowerPoint auto-shrinks text to fit within its container bounds.
PyMOL: 15 slides, DataWarrior: 12 slides, Workshop: 15 slides.

Co-Authored-By: Claude Opus 4.6 (1M context) <noreply@anthropic.com>
</commit_message>
<xml_diff>
--- a/Molecular_Docking_Workshop.pptx
+++ b/Molecular_Docking_Workshop.pptx
@@ -3138,7 +3138,9 @@
           </a:fontRef>
         </p:style>
         <p:txBody>
-          <a:bodyPr rtlCol="0" anchor="ctr"/>
+          <a:bodyPr rtlCol="0" anchor="ctr">
+            <a:normAutofit/>
+          </a:bodyPr>
           <a:lstStyle/>
           <a:p>
             <a:pPr algn="ctr"/>
@@ -3163,7 +3165,7 @@
         </p:spPr>
         <p:txBody>
           <a:bodyPr wrap="square">
-            <a:spAutoFit/>
+            <a:normAutofit/>
           </a:bodyPr>
           <a:lstStyle/>
           <a:p>
@@ -3202,7 +3204,7 @@
         </p:spPr>
         <p:txBody>
           <a:bodyPr wrap="square">
-            <a:spAutoFit/>
+            <a:normAutofit/>
           </a:bodyPr>
           <a:lstStyle/>
           <a:p>
@@ -3241,7 +3243,7 @@
         </p:spPr>
         <p:txBody>
           <a:bodyPr wrap="square">
-            <a:spAutoFit/>
+            <a:normAutofit/>
           </a:bodyPr>
           <a:lstStyle/>
           <a:p>
@@ -3312,7 +3314,7 @@
         </p:spPr>
         <p:txBody>
           <a:bodyPr wrap="square">
-            <a:spAutoFit/>
+            <a:normAutofit/>
           </a:bodyPr>
           <a:lstStyle/>
           <a:p>
@@ -3387,7 +3389,9 @@
           </a:fontRef>
         </p:style>
         <p:txBody>
-          <a:bodyPr rtlCol="0" anchor="ctr"/>
+          <a:bodyPr rtlCol="0" anchor="ctr">
+            <a:normAutofit/>
+          </a:bodyPr>
           <a:lstStyle/>
           <a:p>
             <a:pPr algn="ctr"/>
@@ -3412,7 +3416,7 @@
         </p:spPr>
         <p:txBody>
           <a:bodyPr wrap="square">
-            <a:spAutoFit/>
+            <a:normAutofit/>
           </a:bodyPr>
           <a:lstStyle/>
           <a:p>
@@ -3451,7 +3455,7 @@
         </p:spPr>
         <p:txBody>
           <a:bodyPr wrap="square">
-            <a:spAutoFit/>
+            <a:normAutofit/>
           </a:bodyPr>
           <a:lstStyle/>
           <a:p>
@@ -3508,7 +3512,9 @@
           </a:fontRef>
         </p:style>
         <p:txBody>
-          <a:bodyPr rtlCol="0" anchor="ctr" wrap="square" lIns="177800" tIns="127000" rIns="177800" bIns="127000"/>
+          <a:bodyPr rtlCol="0" anchor="ctr" wrap="square" lIns="177800" tIns="127000" rIns="177800" bIns="127000">
+            <a:normAutofit/>
+          </a:bodyPr>
           <a:lstStyle/>
           <a:p>
             <a:pPr algn="ctr">
@@ -4010,7 +4016,9 @@
           </a:fontRef>
         </p:style>
         <p:txBody>
-          <a:bodyPr rtlCol="0" anchor="ctr" wrap="square" lIns="177800" tIns="127000" rIns="177800" bIns="127000"/>
+          <a:bodyPr rtlCol="0" anchor="ctr" wrap="square" lIns="177800" tIns="127000" rIns="177800" bIns="127000">
+            <a:normAutofit/>
+          </a:bodyPr>
           <a:lstStyle/>
           <a:p>
             <a:pPr algn="ctr">
@@ -4453,7 +4461,9 @@
           </a:fontRef>
         </p:style>
         <p:txBody>
-          <a:bodyPr rtlCol="0" anchor="ctr"/>
+          <a:bodyPr rtlCol="0" anchor="ctr">
+            <a:normAutofit/>
+          </a:bodyPr>
           <a:lstStyle/>
           <a:p>
             <a:pPr algn="ctr"/>
@@ -4478,7 +4488,7 @@
         </p:spPr>
         <p:txBody>
           <a:bodyPr wrap="square">
-            <a:spAutoFit/>
+            <a:normAutofit/>
           </a:bodyPr>
           <a:lstStyle/>
           <a:p>
@@ -4517,7 +4527,7 @@
         </p:spPr>
         <p:txBody>
           <a:bodyPr wrap="square">
-            <a:spAutoFit/>
+            <a:normAutofit/>
           </a:bodyPr>
           <a:lstStyle/>
           <a:p>
@@ -4556,7 +4566,7 @@
         </p:spPr>
         <p:txBody>
           <a:bodyPr wrap="square">
-            <a:spAutoFit/>
+            <a:normAutofit/>
           </a:bodyPr>
           <a:lstStyle/>
           <a:p>
@@ -4613,7 +4623,9 @@
           </a:fontRef>
         </p:style>
         <p:txBody>
-          <a:bodyPr rtlCol="0" anchor="ctr"/>
+          <a:bodyPr rtlCol="0" anchor="ctr">
+            <a:normAutofit/>
+          </a:bodyPr>
           <a:lstStyle/>
           <a:p>
             <a:pPr algn="ctr"/>
@@ -4638,7 +4650,7 @@
         </p:spPr>
         <p:txBody>
           <a:bodyPr wrap="square">
-            <a:spAutoFit/>
+            <a:normAutofit/>
           </a:bodyPr>
           <a:lstStyle/>
           <a:p>
@@ -4677,7 +4689,7 @@
         </p:spPr>
         <p:txBody>
           <a:bodyPr wrap="square">
-            <a:spAutoFit/>
+            <a:normAutofit/>
           </a:bodyPr>
           <a:lstStyle/>
           <a:p>
@@ -4734,7 +4746,9 @@
           </a:fontRef>
         </p:style>
         <p:txBody>
-          <a:bodyPr rtlCol="0" anchor="ctr"/>
+          <a:bodyPr rtlCol="0" anchor="ctr">
+            <a:normAutofit/>
+          </a:bodyPr>
           <a:lstStyle/>
           <a:p>
             <a:pPr algn="ctr"/>
@@ -4759,7 +4773,7 @@
         </p:spPr>
         <p:txBody>
           <a:bodyPr wrap="square">
-            <a:spAutoFit/>
+            <a:normAutofit/>
           </a:bodyPr>
           <a:lstStyle/>
           <a:p>
@@ -4798,7 +4812,7 @@
         </p:spPr>
         <p:txBody>
           <a:bodyPr wrap="square">
-            <a:spAutoFit/>
+            <a:normAutofit/>
           </a:bodyPr>
           <a:lstStyle/>
           <a:p>
@@ -4855,7 +4869,9 @@
           </a:fontRef>
         </p:style>
         <p:txBody>
-          <a:bodyPr rtlCol="0" anchor="ctr"/>
+          <a:bodyPr rtlCol="0" anchor="ctr">
+            <a:normAutofit/>
+          </a:bodyPr>
           <a:lstStyle/>
           <a:p>
             <a:pPr algn="ctr"/>
@@ -4880,7 +4896,7 @@
         </p:spPr>
         <p:txBody>
           <a:bodyPr wrap="square">
-            <a:spAutoFit/>
+            <a:normAutofit/>
           </a:bodyPr>
           <a:lstStyle/>
           <a:p>
@@ -4919,7 +4935,7 @@
         </p:spPr>
         <p:txBody>
           <a:bodyPr wrap="square">
-            <a:spAutoFit/>
+            <a:normAutofit/>
           </a:bodyPr>
           <a:lstStyle/>
           <a:p>
@@ -4976,7 +4992,9 @@
           </a:fontRef>
         </p:style>
         <p:txBody>
-          <a:bodyPr rtlCol="0" anchor="ctr"/>
+          <a:bodyPr rtlCol="0" anchor="ctr">
+            <a:normAutofit/>
+          </a:bodyPr>
           <a:lstStyle/>
           <a:p>
             <a:pPr algn="ctr"/>
@@ -5001,7 +5019,7 @@
         </p:spPr>
         <p:txBody>
           <a:bodyPr wrap="square">
-            <a:spAutoFit/>
+            <a:normAutofit/>
           </a:bodyPr>
           <a:lstStyle/>
           <a:p>
@@ -5040,7 +5058,7 @@
         </p:spPr>
         <p:txBody>
           <a:bodyPr wrap="square">
-            <a:spAutoFit/>
+            <a:normAutofit/>
           </a:bodyPr>
           <a:lstStyle/>
           <a:p>
@@ -5097,7 +5115,9 @@
           </a:fontRef>
         </p:style>
         <p:txBody>
-          <a:bodyPr rtlCol="0" anchor="ctr"/>
+          <a:bodyPr rtlCol="0" anchor="ctr">
+            <a:normAutofit/>
+          </a:bodyPr>
           <a:lstStyle/>
           <a:p>
             <a:pPr algn="ctr"/>
@@ -5122,7 +5142,7 @@
         </p:spPr>
         <p:txBody>
           <a:bodyPr wrap="square">
-            <a:spAutoFit/>
+            <a:normAutofit/>
           </a:bodyPr>
           <a:lstStyle/>
           <a:p>
@@ -5161,7 +5181,7 @@
         </p:spPr>
         <p:txBody>
           <a:bodyPr wrap="square">
-            <a:spAutoFit/>
+            <a:normAutofit/>
           </a:bodyPr>
           <a:lstStyle/>
           <a:p>
@@ -5218,7 +5238,9 @@
           </a:fontRef>
         </p:style>
         <p:txBody>
-          <a:bodyPr rtlCol="0" anchor="ctr"/>
+          <a:bodyPr rtlCol="0" anchor="ctr">
+            <a:normAutofit/>
+          </a:bodyPr>
           <a:lstStyle/>
           <a:p>
             <a:pPr algn="ctr"/>
@@ -5243,7 +5265,7 @@
         </p:spPr>
         <p:txBody>
           <a:bodyPr wrap="square">
-            <a:spAutoFit/>
+            <a:normAutofit/>
           </a:bodyPr>
           <a:lstStyle/>
           <a:p>
@@ -5282,7 +5304,7 @@
         </p:spPr>
         <p:txBody>
           <a:bodyPr wrap="square">
-            <a:spAutoFit/>
+            <a:normAutofit/>
           </a:bodyPr>
           <a:lstStyle/>
           <a:p>
@@ -5321,7 +5343,7 @@
         </p:spPr>
         <p:txBody>
           <a:bodyPr wrap="square">
-            <a:spAutoFit/>
+            <a:normAutofit/>
           </a:bodyPr>
           <a:lstStyle/>
           <a:p>
@@ -5378,7 +5400,9 @@
           </a:fontRef>
         </p:style>
         <p:txBody>
-          <a:bodyPr rtlCol="0" anchor="ctr" wrap="square" lIns="177800" tIns="127000" rIns="177800" bIns="127000"/>
+          <a:bodyPr rtlCol="0" anchor="ctr" wrap="square" lIns="177800" tIns="127000" rIns="177800" bIns="127000">
+            <a:normAutofit/>
+          </a:bodyPr>
           <a:lstStyle/>
           <a:p>
             <a:pPr algn="ctr">
@@ -5516,7 +5540,9 @@
           </a:fontRef>
         </p:style>
         <p:txBody>
-          <a:bodyPr rtlCol="0" anchor="ctr"/>
+          <a:bodyPr rtlCol="0" anchor="ctr">
+            <a:normAutofit/>
+          </a:bodyPr>
           <a:lstStyle/>
           <a:p>
             <a:pPr algn="ctr"/>
@@ -5541,7 +5567,7 @@
         </p:spPr>
         <p:txBody>
           <a:bodyPr wrap="square">
-            <a:spAutoFit/>
+            <a:normAutofit/>
           </a:bodyPr>
           <a:lstStyle/>
           <a:p>
@@ -5598,7 +5624,9 @@
           </a:fontRef>
         </p:style>
         <p:txBody>
-          <a:bodyPr rtlCol="0" anchor="ctr" wrap="square" lIns="177800" tIns="127000" rIns="177800" bIns="127000"/>
+          <a:bodyPr rtlCol="0" anchor="ctr" wrap="square" lIns="177800" tIns="127000" rIns="177800" bIns="127000">
+            <a:normAutofit/>
+          </a:bodyPr>
           <a:lstStyle/>
           <a:p>
             <a:pPr algn="ctr">
@@ -6041,7 +6069,9 @@
           </a:fontRef>
         </p:style>
         <p:txBody>
-          <a:bodyPr rtlCol="0" anchor="ctr"/>
+          <a:bodyPr rtlCol="0" anchor="ctr">
+            <a:normAutofit/>
+          </a:bodyPr>
           <a:lstStyle/>
           <a:p>
             <a:pPr algn="ctr"/>
@@ -6066,7 +6096,7 @@
         </p:spPr>
         <p:txBody>
           <a:bodyPr wrap="square">
-            <a:spAutoFit/>
+            <a:normAutofit/>
           </a:bodyPr>
           <a:lstStyle/>
           <a:p>
@@ -6105,7 +6135,7 @@
         </p:spPr>
         <p:txBody>
           <a:bodyPr wrap="square">
-            <a:spAutoFit/>
+            <a:normAutofit/>
           </a:bodyPr>
           <a:lstStyle/>
           <a:p>
@@ -6162,7 +6192,9 @@
           </a:fontRef>
         </p:style>
         <p:txBody>
-          <a:bodyPr rtlCol="0" anchor="ctr" wrap="square"/>
+          <a:bodyPr rtlCol="0" anchor="ctr" wrap="square">
+            <a:normAutofit/>
+          </a:bodyPr>
           <a:lstStyle/>
           <a:p>
             <a:pPr algn="ctr">
@@ -6214,7 +6246,9 @@
           </a:fontRef>
         </p:style>
         <p:txBody>
-          <a:bodyPr rtlCol="0" anchor="ctr" wrap="square"/>
+          <a:bodyPr rtlCol="0" anchor="ctr" wrap="square">
+            <a:normAutofit/>
+          </a:bodyPr>
           <a:lstStyle/>
           <a:p>
             <a:pPr algn="ctr">
@@ -6266,7 +6300,9 @@
           </a:fontRef>
         </p:style>
         <p:txBody>
-          <a:bodyPr rtlCol="0" anchor="ctr" wrap="square"/>
+          <a:bodyPr rtlCol="0" anchor="ctr" wrap="square">
+            <a:normAutofit/>
+          </a:bodyPr>
           <a:lstStyle/>
           <a:p>
             <a:pPr algn="ctr">
@@ -6318,7 +6354,9 @@
           </a:fontRef>
         </p:style>
         <p:txBody>
-          <a:bodyPr rtlCol="0" anchor="ctr" wrap="square"/>
+          <a:bodyPr rtlCol="0" anchor="ctr" wrap="square">
+            <a:normAutofit/>
+          </a:bodyPr>
           <a:lstStyle/>
           <a:p>
             <a:pPr algn="ctr">
@@ -6370,7 +6408,9 @@
           </a:fontRef>
         </p:style>
         <p:txBody>
-          <a:bodyPr rtlCol="0" anchor="ctr" wrap="square"/>
+          <a:bodyPr rtlCol="0" anchor="ctr" wrap="square">
+            <a:normAutofit/>
+          </a:bodyPr>
           <a:lstStyle/>
           <a:p>
             <a:pPr algn="ctr">
@@ -6424,7 +6464,9 @@
           </a:fontRef>
         </p:style>
         <p:txBody>
-          <a:bodyPr rtlCol="0" anchor="ctr"/>
+          <a:bodyPr rtlCol="0" anchor="ctr">
+            <a:normAutofit/>
+          </a:bodyPr>
           <a:lstStyle/>
           <a:p>
             <a:pPr algn="ctr">
@@ -6474,7 +6516,9 @@
           </a:fontRef>
         </p:style>
         <p:txBody>
-          <a:bodyPr rtlCol="0" anchor="ctr"/>
+          <a:bodyPr rtlCol="0" anchor="ctr">
+            <a:normAutofit/>
+          </a:bodyPr>
           <a:lstStyle/>
           <a:p>
             <a:pPr algn="ctr">
@@ -6524,7 +6568,9 @@
           </a:fontRef>
         </p:style>
         <p:txBody>
-          <a:bodyPr rtlCol="0" anchor="ctr"/>
+          <a:bodyPr rtlCol="0" anchor="ctr">
+            <a:normAutofit/>
+          </a:bodyPr>
           <a:lstStyle/>
           <a:p>
             <a:pPr algn="ctr">
@@ -6574,7 +6620,9 @@
           </a:fontRef>
         </p:style>
         <p:txBody>
-          <a:bodyPr rtlCol="0" anchor="ctr"/>
+          <a:bodyPr rtlCol="0" anchor="ctr">
+            <a:normAutofit/>
+          </a:bodyPr>
           <a:lstStyle/>
           <a:p>
             <a:pPr algn="ctr">
@@ -6624,7 +6672,9 @@
           </a:fontRef>
         </p:style>
         <p:txBody>
-          <a:bodyPr rtlCol="0" anchor="ctr"/>
+          <a:bodyPr rtlCol="0" anchor="ctr">
+            <a:normAutofit/>
+          </a:bodyPr>
           <a:lstStyle/>
           <a:p>
             <a:pPr algn="ctr">
@@ -6674,7 +6724,9 @@
           </a:fontRef>
         </p:style>
         <p:txBody>
-          <a:bodyPr rtlCol="0" anchor="ctr"/>
+          <a:bodyPr rtlCol="0" anchor="ctr">
+            <a:normAutofit/>
+          </a:bodyPr>
           <a:lstStyle/>
           <a:p>
             <a:pPr algn="ctr">
@@ -6724,7 +6776,9 @@
           </a:fontRef>
         </p:style>
         <p:txBody>
-          <a:bodyPr rtlCol="0" anchor="ctr"/>
+          <a:bodyPr rtlCol="0" anchor="ctr">
+            <a:normAutofit/>
+          </a:bodyPr>
           <a:lstStyle/>
           <a:p>
             <a:pPr algn="ctr">
@@ -6774,7 +6828,9 @@
           </a:fontRef>
         </p:style>
         <p:txBody>
-          <a:bodyPr rtlCol="0" anchor="ctr"/>
+          <a:bodyPr rtlCol="0" anchor="ctr">
+            <a:normAutofit/>
+          </a:bodyPr>
           <a:lstStyle/>
           <a:p>
             <a:pPr algn="ctr">
@@ -6824,7 +6880,9 @@
           </a:fontRef>
         </p:style>
         <p:txBody>
-          <a:bodyPr rtlCol="0" anchor="ctr"/>
+          <a:bodyPr rtlCol="0" anchor="ctr">
+            <a:normAutofit/>
+          </a:bodyPr>
           <a:lstStyle/>
           <a:p>
             <a:pPr algn="ctr">
@@ -6874,7 +6932,9 @@
           </a:fontRef>
         </p:style>
         <p:txBody>
-          <a:bodyPr rtlCol="0" anchor="ctr"/>
+          <a:bodyPr rtlCol="0" anchor="ctr">
+            <a:normAutofit/>
+          </a:bodyPr>
           <a:lstStyle/>
           <a:p>
             <a:pPr algn="ctr">
@@ -6924,7 +6984,9 @@
           </a:fontRef>
         </p:style>
         <p:txBody>
-          <a:bodyPr rtlCol="0" anchor="ctr"/>
+          <a:bodyPr rtlCol="0" anchor="ctr">
+            <a:normAutofit/>
+          </a:bodyPr>
           <a:lstStyle/>
           <a:p>
             <a:pPr algn="ctr">
@@ -6974,7 +7036,9 @@
           </a:fontRef>
         </p:style>
         <p:txBody>
-          <a:bodyPr rtlCol="0" anchor="ctr"/>
+          <a:bodyPr rtlCol="0" anchor="ctr">
+            <a:normAutofit/>
+          </a:bodyPr>
           <a:lstStyle/>
           <a:p>
             <a:pPr algn="ctr">
@@ -7024,7 +7088,9 @@
           </a:fontRef>
         </p:style>
         <p:txBody>
-          <a:bodyPr rtlCol="0" anchor="ctr"/>
+          <a:bodyPr rtlCol="0" anchor="ctr">
+            <a:normAutofit/>
+          </a:bodyPr>
           <a:lstStyle/>
           <a:p>
             <a:pPr algn="ctr">
@@ -7074,7 +7140,9 @@
           </a:fontRef>
         </p:style>
         <p:txBody>
-          <a:bodyPr rtlCol="0" anchor="ctr"/>
+          <a:bodyPr rtlCol="0" anchor="ctr">
+            <a:normAutofit/>
+          </a:bodyPr>
           <a:lstStyle/>
           <a:p>
             <a:pPr algn="ctr">
@@ -7124,7 +7192,9 @@
           </a:fontRef>
         </p:style>
         <p:txBody>
-          <a:bodyPr rtlCol="0" anchor="ctr"/>
+          <a:bodyPr rtlCol="0" anchor="ctr">
+            <a:normAutofit/>
+          </a:bodyPr>
           <a:lstStyle/>
           <a:p>
             <a:pPr algn="ctr">
@@ -7174,7 +7244,9 @@
           </a:fontRef>
         </p:style>
         <p:txBody>
-          <a:bodyPr rtlCol="0" anchor="ctr"/>
+          <a:bodyPr rtlCol="0" anchor="ctr">
+            <a:normAutofit/>
+          </a:bodyPr>
           <a:lstStyle/>
           <a:p>
             <a:pPr algn="ctr">
@@ -7224,7 +7296,9 @@
           </a:fontRef>
         </p:style>
         <p:txBody>
-          <a:bodyPr rtlCol="0" anchor="ctr"/>
+          <a:bodyPr rtlCol="0" anchor="ctr">
+            <a:normAutofit/>
+          </a:bodyPr>
           <a:lstStyle/>
           <a:p>
             <a:pPr algn="ctr">
@@ -7274,7 +7348,9 @@
           </a:fontRef>
         </p:style>
         <p:txBody>
-          <a:bodyPr rtlCol="0" anchor="ctr"/>
+          <a:bodyPr rtlCol="0" anchor="ctr">
+            <a:normAutofit/>
+          </a:bodyPr>
           <a:lstStyle/>
           <a:p>
             <a:pPr algn="ctr">
@@ -7324,7 +7400,9 @@
           </a:fontRef>
         </p:style>
         <p:txBody>
-          <a:bodyPr rtlCol="0" anchor="ctr"/>
+          <a:bodyPr rtlCol="0" anchor="ctr">
+            <a:normAutofit/>
+          </a:bodyPr>
           <a:lstStyle/>
           <a:p>
             <a:pPr algn="ctr">
@@ -7374,7 +7452,9 @@
           </a:fontRef>
         </p:style>
         <p:txBody>
-          <a:bodyPr rtlCol="0" anchor="ctr"/>
+          <a:bodyPr rtlCol="0" anchor="ctr">
+            <a:normAutofit/>
+          </a:bodyPr>
           <a:lstStyle/>
           <a:p>
             <a:pPr algn="ctr">
@@ -7424,7 +7504,9 @@
           </a:fontRef>
         </p:style>
         <p:txBody>
-          <a:bodyPr rtlCol="0" anchor="ctr"/>
+          <a:bodyPr rtlCol="0" anchor="ctr">
+            <a:normAutofit/>
+          </a:bodyPr>
           <a:lstStyle/>
           <a:p>
             <a:pPr algn="ctr">
@@ -7474,7 +7556,9 @@
           </a:fontRef>
         </p:style>
         <p:txBody>
-          <a:bodyPr rtlCol="0" anchor="ctr"/>
+          <a:bodyPr rtlCol="0" anchor="ctr">
+            <a:normAutofit/>
+          </a:bodyPr>
           <a:lstStyle/>
           <a:p>
             <a:pPr algn="ctr">
@@ -7524,7 +7608,9 @@
           </a:fontRef>
         </p:style>
         <p:txBody>
-          <a:bodyPr rtlCol="0" anchor="ctr"/>
+          <a:bodyPr rtlCol="0" anchor="ctr">
+            <a:normAutofit/>
+          </a:bodyPr>
           <a:lstStyle/>
           <a:p>
             <a:pPr algn="ctr">
@@ -7574,7 +7660,9 @@
           </a:fontRef>
         </p:style>
         <p:txBody>
-          <a:bodyPr rtlCol="0" anchor="ctr"/>
+          <a:bodyPr rtlCol="0" anchor="ctr">
+            <a:normAutofit/>
+          </a:bodyPr>
           <a:lstStyle/>
           <a:p>
             <a:pPr algn="ctr">
@@ -7624,7 +7712,9 @@
           </a:fontRef>
         </p:style>
         <p:txBody>
-          <a:bodyPr rtlCol="0" anchor="ctr"/>
+          <a:bodyPr rtlCol="0" anchor="ctr">
+            <a:normAutofit/>
+          </a:bodyPr>
           <a:lstStyle/>
           <a:p>
             <a:pPr algn="ctr">
@@ -7674,7 +7764,9 @@
           </a:fontRef>
         </p:style>
         <p:txBody>
-          <a:bodyPr rtlCol="0" anchor="ctr"/>
+          <a:bodyPr rtlCol="0" anchor="ctr">
+            <a:normAutofit/>
+          </a:bodyPr>
           <a:lstStyle/>
           <a:p>
             <a:pPr algn="ctr">
@@ -7724,7 +7816,9 @@
           </a:fontRef>
         </p:style>
         <p:txBody>
-          <a:bodyPr rtlCol="0" anchor="ctr"/>
+          <a:bodyPr rtlCol="0" anchor="ctr">
+            <a:normAutofit/>
+          </a:bodyPr>
           <a:lstStyle/>
           <a:p>
             <a:pPr algn="ctr">
@@ -7774,7 +7868,9 @@
           </a:fontRef>
         </p:style>
         <p:txBody>
-          <a:bodyPr rtlCol="0" anchor="ctr"/>
+          <a:bodyPr rtlCol="0" anchor="ctr">
+            <a:normAutofit/>
+          </a:bodyPr>
           <a:lstStyle/>
           <a:p>
             <a:pPr algn="ctr">
@@ -7824,7 +7920,9 @@
           </a:fontRef>
         </p:style>
         <p:txBody>
-          <a:bodyPr rtlCol="0" anchor="ctr"/>
+          <a:bodyPr rtlCol="0" anchor="ctr">
+            <a:normAutofit/>
+          </a:bodyPr>
           <a:lstStyle/>
           <a:p>
             <a:pPr algn="ctr">
@@ -7874,7 +7972,9 @@
           </a:fontRef>
         </p:style>
         <p:txBody>
-          <a:bodyPr rtlCol="0" anchor="ctr"/>
+          <a:bodyPr rtlCol="0" anchor="ctr">
+            <a:normAutofit/>
+          </a:bodyPr>
           <a:lstStyle/>
           <a:p>
             <a:pPr algn="ctr">
@@ -7924,7 +8024,9 @@
           </a:fontRef>
         </p:style>
         <p:txBody>
-          <a:bodyPr rtlCol="0" anchor="ctr"/>
+          <a:bodyPr rtlCol="0" anchor="ctr">
+            <a:normAutofit/>
+          </a:bodyPr>
           <a:lstStyle/>
           <a:p>
             <a:pPr algn="ctr">
@@ -7974,7 +8076,9 @@
           </a:fontRef>
         </p:style>
         <p:txBody>
-          <a:bodyPr rtlCol="0" anchor="ctr"/>
+          <a:bodyPr rtlCol="0" anchor="ctr">
+            <a:normAutofit/>
+          </a:bodyPr>
           <a:lstStyle/>
           <a:p>
             <a:pPr algn="ctr">
@@ -8024,7 +8128,9 @@
           </a:fontRef>
         </p:style>
         <p:txBody>
-          <a:bodyPr rtlCol="0" anchor="ctr"/>
+          <a:bodyPr rtlCol="0" anchor="ctr">
+            <a:normAutofit/>
+          </a:bodyPr>
           <a:lstStyle/>
           <a:p>
             <a:pPr algn="ctr">
@@ -8074,7 +8180,9 @@
           </a:fontRef>
         </p:style>
         <p:txBody>
-          <a:bodyPr rtlCol="0" anchor="ctr"/>
+          <a:bodyPr rtlCol="0" anchor="ctr">
+            <a:normAutofit/>
+          </a:bodyPr>
           <a:lstStyle/>
           <a:p>
             <a:pPr algn="ctr">
@@ -8124,7 +8232,9 @@
           </a:fontRef>
         </p:style>
         <p:txBody>
-          <a:bodyPr rtlCol="0" anchor="ctr"/>
+          <a:bodyPr rtlCol="0" anchor="ctr">
+            <a:normAutofit/>
+          </a:bodyPr>
           <a:lstStyle/>
           <a:p>
             <a:pPr algn="ctr">
@@ -8174,7 +8284,9 @@
           </a:fontRef>
         </p:style>
         <p:txBody>
-          <a:bodyPr rtlCol="0" anchor="ctr"/>
+          <a:bodyPr rtlCol="0" anchor="ctr">
+            <a:normAutofit/>
+          </a:bodyPr>
           <a:lstStyle/>
           <a:p>
             <a:pPr algn="ctr">
@@ -8224,7 +8336,9 @@
           </a:fontRef>
         </p:style>
         <p:txBody>
-          <a:bodyPr rtlCol="0" anchor="ctr"/>
+          <a:bodyPr rtlCol="0" anchor="ctr">
+            <a:normAutofit/>
+          </a:bodyPr>
           <a:lstStyle/>
           <a:p>
             <a:pPr algn="ctr">
@@ -8274,7 +8388,9 @@
           </a:fontRef>
         </p:style>
         <p:txBody>
-          <a:bodyPr rtlCol="0" anchor="ctr"/>
+          <a:bodyPr rtlCol="0" anchor="ctr">
+            <a:normAutofit/>
+          </a:bodyPr>
           <a:lstStyle/>
           <a:p>
             <a:pPr algn="ctr">
@@ -8324,7 +8440,9 @@
           </a:fontRef>
         </p:style>
         <p:txBody>
-          <a:bodyPr rtlCol="0" anchor="ctr"/>
+          <a:bodyPr rtlCol="0" anchor="ctr">
+            <a:normAutofit/>
+          </a:bodyPr>
           <a:lstStyle/>
           <a:p>
             <a:pPr algn="ctr">
@@ -8374,7 +8492,9 @@
           </a:fontRef>
         </p:style>
         <p:txBody>
-          <a:bodyPr rtlCol="0" anchor="ctr"/>
+          <a:bodyPr rtlCol="0" anchor="ctr">
+            <a:normAutofit/>
+          </a:bodyPr>
           <a:lstStyle/>
           <a:p>
             <a:pPr algn="ctr">
@@ -8424,7 +8544,9 @@
           </a:fontRef>
         </p:style>
         <p:txBody>
-          <a:bodyPr rtlCol="0" anchor="ctr"/>
+          <a:bodyPr rtlCol="0" anchor="ctr">
+            <a:normAutofit/>
+          </a:bodyPr>
           <a:lstStyle/>
           <a:p>
             <a:pPr algn="ctr">
@@ -8474,7 +8596,9 @@
           </a:fontRef>
         </p:style>
         <p:txBody>
-          <a:bodyPr rtlCol="0" anchor="ctr"/>
+          <a:bodyPr rtlCol="0" anchor="ctr">
+            <a:normAutofit/>
+          </a:bodyPr>
           <a:lstStyle/>
           <a:p>
             <a:pPr algn="ctr">
@@ -8524,7 +8648,9 @@
           </a:fontRef>
         </p:style>
         <p:txBody>
-          <a:bodyPr rtlCol="0" anchor="ctr"/>
+          <a:bodyPr rtlCol="0" anchor="ctr">
+            <a:normAutofit/>
+          </a:bodyPr>
           <a:lstStyle/>
           <a:p>
             <a:pPr algn="ctr">
@@ -8574,7 +8700,9 @@
           </a:fontRef>
         </p:style>
         <p:txBody>
-          <a:bodyPr rtlCol="0" anchor="ctr"/>
+          <a:bodyPr rtlCol="0" anchor="ctr">
+            <a:normAutofit/>
+          </a:bodyPr>
           <a:lstStyle/>
           <a:p>
             <a:pPr algn="ctr">
@@ -8624,7 +8752,9 @@
           </a:fontRef>
         </p:style>
         <p:txBody>
-          <a:bodyPr rtlCol="0" anchor="ctr"/>
+          <a:bodyPr rtlCol="0" anchor="ctr">
+            <a:normAutofit/>
+          </a:bodyPr>
           <a:lstStyle/>
           <a:p>
             <a:pPr algn="ctr">
@@ -8674,7 +8804,9 @@
           </a:fontRef>
         </p:style>
         <p:txBody>
-          <a:bodyPr rtlCol="0" anchor="ctr"/>
+          <a:bodyPr rtlCol="0" anchor="ctr">
+            <a:normAutofit/>
+          </a:bodyPr>
           <a:lstStyle/>
           <a:p>
             <a:pPr algn="ctr">
@@ -8724,7 +8856,9 @@
           </a:fontRef>
         </p:style>
         <p:txBody>
-          <a:bodyPr rtlCol="0" anchor="ctr"/>
+          <a:bodyPr rtlCol="0" anchor="ctr">
+            <a:normAutofit/>
+          </a:bodyPr>
           <a:lstStyle/>
           <a:p>
             <a:pPr algn="ctr">
@@ -8774,7 +8908,9 @@
           </a:fontRef>
         </p:style>
         <p:txBody>
-          <a:bodyPr rtlCol="0" anchor="ctr"/>
+          <a:bodyPr rtlCol="0" anchor="ctr">
+            <a:normAutofit/>
+          </a:bodyPr>
           <a:lstStyle/>
           <a:p>
             <a:pPr algn="ctr">
@@ -8824,7 +8960,9 @@
           </a:fontRef>
         </p:style>
         <p:txBody>
-          <a:bodyPr rtlCol="0" anchor="ctr"/>
+          <a:bodyPr rtlCol="0" anchor="ctr">
+            <a:normAutofit/>
+          </a:bodyPr>
           <a:lstStyle/>
           <a:p>
             <a:pPr algn="ctr">
@@ -8874,7 +9012,9 @@
           </a:fontRef>
         </p:style>
         <p:txBody>
-          <a:bodyPr rtlCol="0" anchor="ctr"/>
+          <a:bodyPr rtlCol="0" anchor="ctr">
+            <a:normAutofit/>
+          </a:bodyPr>
           <a:lstStyle/>
           <a:p>
             <a:pPr algn="ctr">
@@ -8924,7 +9064,9 @@
           </a:fontRef>
         </p:style>
         <p:txBody>
-          <a:bodyPr rtlCol="0" anchor="ctr"/>
+          <a:bodyPr rtlCol="0" anchor="ctr">
+            <a:normAutofit/>
+          </a:bodyPr>
           <a:lstStyle/>
           <a:p>
             <a:pPr algn="ctr"/>
@@ -8949,7 +9091,7 @@
         </p:spPr>
         <p:txBody>
           <a:bodyPr wrap="square">
-            <a:spAutoFit/>
+            <a:normAutofit/>
           </a:bodyPr>
           <a:lstStyle/>
           <a:p>
@@ -8988,7 +9130,7 @@
         </p:spPr>
         <p:txBody>
           <a:bodyPr wrap="square">
-            <a:spAutoFit/>
+            <a:normAutofit/>
           </a:bodyPr>
           <a:lstStyle/>
           <a:p>
@@ -9027,7 +9169,7 @@
         </p:spPr>
         <p:txBody>
           <a:bodyPr wrap="square">
-            <a:spAutoFit/>
+            <a:normAutofit/>
           </a:bodyPr>
           <a:lstStyle/>
           <a:p>
@@ -9066,7 +9208,7 @@
         </p:spPr>
         <p:txBody>
           <a:bodyPr wrap="square">
-            <a:spAutoFit/>
+            <a:normAutofit/>
           </a:bodyPr>
           <a:lstStyle/>
           <a:p>
@@ -9105,7 +9247,7 @@
         </p:spPr>
         <p:txBody>
           <a:bodyPr wrap="square">
-            <a:spAutoFit/>
+            <a:normAutofit/>
           </a:bodyPr>
           <a:lstStyle/>
           <a:p>
@@ -9144,7 +9286,7 @@
         </p:spPr>
         <p:txBody>
           <a:bodyPr wrap="square">
-            <a:spAutoFit/>
+            <a:normAutofit/>
           </a:bodyPr>
           <a:lstStyle/>
           <a:p>
@@ -9183,7 +9325,7 @@
         </p:spPr>
         <p:txBody>
           <a:bodyPr wrap="square">
-            <a:spAutoFit/>
+            <a:normAutofit/>
           </a:bodyPr>
           <a:lstStyle/>
           <a:p>
@@ -9222,7 +9364,7 @@
         </p:spPr>
         <p:txBody>
           <a:bodyPr wrap="square">
-            <a:spAutoFit/>
+            <a:normAutofit/>
           </a:bodyPr>
           <a:lstStyle/>
           <a:p>
@@ -9261,7 +9403,7 @@
         </p:spPr>
         <p:txBody>
           <a:bodyPr wrap="square">
-            <a:spAutoFit/>
+            <a:normAutofit/>
           </a:bodyPr>
           <a:lstStyle/>
           <a:p>
@@ -9352,7 +9494,9 @@
           </a:fontRef>
         </p:style>
         <p:txBody>
-          <a:bodyPr rtlCol="0" anchor="ctr"/>
+          <a:bodyPr rtlCol="0" anchor="ctr">
+            <a:normAutofit/>
+          </a:bodyPr>
           <a:lstStyle/>
           <a:p>
             <a:pPr algn="ctr"/>
@@ -9377,7 +9521,7 @@
         </p:spPr>
         <p:txBody>
           <a:bodyPr wrap="square">
-            <a:spAutoFit/>
+            <a:normAutofit/>
           </a:bodyPr>
           <a:lstStyle/>
           <a:p>
@@ -9416,7 +9560,7 @@
         </p:spPr>
         <p:txBody>
           <a:bodyPr wrap="square">
-            <a:spAutoFit/>
+            <a:normAutofit/>
           </a:bodyPr>
           <a:lstStyle/>
           <a:p>
@@ -9455,7 +9599,7 @@
         </p:spPr>
         <p:txBody>
           <a:bodyPr wrap="square">
-            <a:spAutoFit/>
+            <a:normAutofit/>
           </a:bodyPr>
           <a:lstStyle/>
           <a:p>
@@ -9512,7 +9656,9 @@
           </a:fontRef>
         </p:style>
         <p:txBody>
-          <a:bodyPr rtlCol="0" anchor="ctr"/>
+          <a:bodyPr rtlCol="0" anchor="ctr">
+            <a:normAutofit/>
+          </a:bodyPr>
           <a:lstStyle/>
           <a:p>
             <a:pPr algn="ctr"/>
@@ -9537,7 +9683,7 @@
         </p:spPr>
         <p:txBody>
           <a:bodyPr wrap="square">
-            <a:spAutoFit/>
+            <a:normAutofit/>
           </a:bodyPr>
           <a:lstStyle/>
           <a:p>
@@ -9576,7 +9722,7 @@
         </p:spPr>
         <p:txBody>
           <a:bodyPr wrap="square">
-            <a:spAutoFit/>
+            <a:normAutofit/>
           </a:bodyPr>
           <a:lstStyle/>
           <a:p>
@@ -9615,7 +9761,7 @@
         </p:spPr>
         <p:txBody>
           <a:bodyPr wrap="square">
-            <a:spAutoFit/>
+            <a:normAutofit/>
           </a:bodyPr>
           <a:lstStyle/>
           <a:p>
@@ -9672,7 +9818,9 @@
           </a:fontRef>
         </p:style>
         <p:txBody>
-          <a:bodyPr rtlCol="0" anchor="ctr"/>
+          <a:bodyPr rtlCol="0" anchor="ctr">
+            <a:normAutofit/>
+          </a:bodyPr>
           <a:lstStyle/>
           <a:p>
             <a:pPr algn="ctr"/>
@@ -9697,7 +9845,7 @@
         </p:spPr>
         <p:txBody>
           <a:bodyPr wrap="square">
-            <a:spAutoFit/>
+            <a:normAutofit/>
           </a:bodyPr>
           <a:lstStyle/>
           <a:p>
@@ -9736,7 +9884,7 @@
         </p:spPr>
         <p:txBody>
           <a:bodyPr wrap="square">
-            <a:spAutoFit/>
+            <a:normAutofit/>
           </a:bodyPr>
           <a:lstStyle/>
           <a:p>
@@ -9775,7 +9923,7 @@
         </p:spPr>
         <p:txBody>
           <a:bodyPr wrap="square">
-            <a:spAutoFit/>
+            <a:normAutofit/>
           </a:bodyPr>
           <a:lstStyle/>
           <a:p>
@@ -9832,7 +9980,9 @@
           </a:fontRef>
         </p:style>
         <p:txBody>
-          <a:bodyPr rtlCol="0" anchor="ctr"/>
+          <a:bodyPr rtlCol="0" anchor="ctr">
+            <a:normAutofit/>
+          </a:bodyPr>
           <a:lstStyle/>
           <a:p>
             <a:pPr algn="ctr"/>
@@ -9857,7 +10007,7 @@
         </p:spPr>
         <p:txBody>
           <a:bodyPr wrap="square">
-            <a:spAutoFit/>
+            <a:normAutofit/>
           </a:bodyPr>
           <a:lstStyle/>
           <a:p>
@@ -9896,7 +10046,7 @@
         </p:spPr>
         <p:txBody>
           <a:bodyPr wrap="square">
-            <a:spAutoFit/>
+            <a:normAutofit/>
           </a:bodyPr>
           <a:lstStyle/>
           <a:p>
@@ -9935,7 +10085,7 @@
         </p:spPr>
         <p:txBody>
           <a:bodyPr wrap="square">
-            <a:spAutoFit/>
+            <a:normAutofit/>
           </a:bodyPr>
           <a:lstStyle/>
           <a:p>
@@ -9992,7 +10142,9 @@
           </a:fontRef>
         </p:style>
         <p:txBody>
-          <a:bodyPr rtlCol="0" anchor="ctr"/>
+          <a:bodyPr rtlCol="0" anchor="ctr">
+            <a:normAutofit/>
+          </a:bodyPr>
           <a:lstStyle/>
           <a:p>
             <a:pPr algn="ctr"/>
@@ -10017,7 +10169,7 @@
         </p:spPr>
         <p:txBody>
           <a:bodyPr wrap="square">
-            <a:spAutoFit/>
+            <a:normAutofit/>
           </a:bodyPr>
           <a:lstStyle/>
           <a:p>
@@ -10056,7 +10208,7 @@
         </p:spPr>
         <p:txBody>
           <a:bodyPr wrap="square">
-            <a:spAutoFit/>
+            <a:normAutofit/>
           </a:bodyPr>
           <a:lstStyle/>
           <a:p>
@@ -10095,7 +10247,7 @@
         </p:spPr>
         <p:txBody>
           <a:bodyPr wrap="square">
-            <a:spAutoFit/>
+            <a:normAutofit/>
           </a:bodyPr>
           <a:lstStyle/>
           <a:p>
@@ -10134,7 +10286,7 @@
         </p:spPr>
         <p:txBody>
           <a:bodyPr wrap="square">
-            <a:spAutoFit/>
+            <a:normAutofit/>
           </a:bodyPr>
           <a:lstStyle/>
           <a:p>
@@ -10173,7 +10325,7 @@
         </p:spPr>
         <p:txBody>
           <a:bodyPr wrap="square">
-            <a:spAutoFit/>
+            <a:normAutofit/>
           </a:bodyPr>
           <a:lstStyle/>
           <a:p>
@@ -10212,7 +10364,7 @@
         </p:spPr>
         <p:txBody>
           <a:bodyPr wrap="square">
-            <a:spAutoFit/>
+            <a:normAutofit/>
           </a:bodyPr>
           <a:lstStyle/>
           <a:p>
@@ -10251,7 +10403,7 @@
         </p:spPr>
         <p:txBody>
           <a:bodyPr wrap="square">
-            <a:spAutoFit/>
+            <a:normAutofit/>
           </a:bodyPr>
           <a:lstStyle/>
           <a:p>
@@ -10290,7 +10442,7 @@
         </p:spPr>
         <p:txBody>
           <a:bodyPr wrap="square">
-            <a:spAutoFit/>
+            <a:normAutofit/>
           </a:bodyPr>
           <a:lstStyle/>
           <a:p>
@@ -10329,7 +10481,7 @@
         </p:spPr>
         <p:txBody>
           <a:bodyPr wrap="square">
-            <a:spAutoFit/>
+            <a:normAutofit/>
           </a:bodyPr>
           <a:lstStyle/>
           <a:p>
@@ -10368,7 +10520,7 @@
         </p:spPr>
         <p:txBody>
           <a:bodyPr wrap="square">
-            <a:spAutoFit/>
+            <a:normAutofit/>
           </a:bodyPr>
           <a:lstStyle/>
           <a:p>
@@ -10407,7 +10559,7 @@
         </p:spPr>
         <p:txBody>
           <a:bodyPr wrap="square">
-            <a:spAutoFit/>
+            <a:normAutofit/>
           </a:bodyPr>
           <a:lstStyle/>
           <a:p>
@@ -10446,7 +10598,7 @@
         </p:spPr>
         <p:txBody>
           <a:bodyPr wrap="square">
-            <a:spAutoFit/>
+            <a:normAutofit/>
           </a:bodyPr>
           <a:lstStyle/>
           <a:p>
@@ -10485,7 +10637,7 @@
         </p:spPr>
         <p:txBody>
           <a:bodyPr wrap="square">
-            <a:spAutoFit/>
+            <a:normAutofit/>
           </a:bodyPr>
           <a:lstStyle/>
           <a:p>
@@ -10524,7 +10676,7 @@
         </p:spPr>
         <p:txBody>
           <a:bodyPr wrap="square">
-            <a:spAutoFit/>
+            <a:normAutofit/>
           </a:bodyPr>
           <a:lstStyle/>
           <a:p>
@@ -10563,7 +10715,7 @@
         </p:spPr>
         <p:txBody>
           <a:bodyPr wrap="square">
-            <a:spAutoFit/>
+            <a:normAutofit/>
           </a:bodyPr>
           <a:lstStyle/>
           <a:p>
@@ -10602,7 +10754,7 @@
         </p:spPr>
         <p:txBody>
           <a:bodyPr wrap="square">
-            <a:spAutoFit/>
+            <a:normAutofit/>
           </a:bodyPr>
           <a:lstStyle/>
           <a:p>
@@ -10661,7 +10813,9 @@
           </a:fontRef>
         </p:style>
         <p:txBody>
-          <a:bodyPr rtlCol="0" anchor="ctr"/>
+          <a:bodyPr rtlCol="0" anchor="ctr">
+            <a:normAutofit/>
+          </a:bodyPr>
           <a:lstStyle/>
           <a:p>
             <a:pPr algn="ctr"/>
@@ -10686,7 +10840,7 @@
         </p:spPr>
         <p:txBody>
           <a:bodyPr wrap="square">
-            <a:spAutoFit/>
+            <a:normAutofit/>
           </a:bodyPr>
           <a:lstStyle/>
           <a:p>
@@ -10743,7 +10897,9 @@
           </a:fontRef>
         </p:style>
         <p:txBody>
-          <a:bodyPr rtlCol="0" anchor="ctr" wrap="square" lIns="177800" tIns="127000" rIns="177800" bIns="127000"/>
+          <a:bodyPr rtlCol="0" anchor="ctr" wrap="square" lIns="177800" tIns="127000" rIns="177800" bIns="127000">
+            <a:normAutofit/>
+          </a:bodyPr>
           <a:lstStyle/>
           <a:p>
             <a:pPr algn="ctr">
@@ -11096,7 +11252,9 @@
           </a:fontRef>
         </p:style>
         <p:txBody>
-          <a:bodyPr rtlCol="0" anchor="ctr"/>
+          <a:bodyPr rtlCol="0" anchor="ctr">
+            <a:normAutofit/>
+          </a:bodyPr>
           <a:lstStyle/>
           <a:p>
             <a:pPr algn="ctr"/>
@@ -11121,7 +11279,7 @@
         </p:spPr>
         <p:txBody>
           <a:bodyPr wrap="square">
-            <a:spAutoFit/>
+            <a:normAutofit/>
           </a:bodyPr>
           <a:lstStyle/>
           <a:p>
@@ -11160,7 +11318,7 @@
         </p:spPr>
         <p:txBody>
           <a:bodyPr wrap="square">
-            <a:spAutoFit/>
+            <a:normAutofit/>
           </a:bodyPr>
           <a:lstStyle/>
           <a:p>
@@ -11217,7 +11375,9 @@
           </a:fontRef>
         </p:style>
         <p:txBody>
-          <a:bodyPr rtlCol="0" anchor="ctr" lIns="127000"/>
+          <a:bodyPr rtlCol="0" anchor="ctr" lIns="127000">
+            <a:normAutofit/>
+          </a:bodyPr>
           <a:lstStyle/>
           <a:p>
             <a:pPr algn="ctr"/>
@@ -11278,7 +11438,9 @@
           </a:fontRef>
         </p:style>
         <p:txBody>
-          <a:bodyPr rtlCol="0" anchor="ctr" lIns="127000"/>
+          <a:bodyPr rtlCol="0" anchor="ctr" lIns="127000">
+            <a:normAutofit/>
+          </a:bodyPr>
           <a:lstStyle/>
           <a:p>
             <a:pPr algn="ctr"/>
@@ -11339,7 +11501,9 @@
           </a:fontRef>
         </p:style>
         <p:txBody>
-          <a:bodyPr rtlCol="0" anchor="ctr" lIns="127000"/>
+          <a:bodyPr rtlCol="0" anchor="ctr" lIns="127000">
+            <a:normAutofit/>
+          </a:bodyPr>
           <a:lstStyle/>
           <a:p>
             <a:pPr algn="ctr"/>
@@ -11400,7 +11564,9 @@
           </a:fontRef>
         </p:style>
         <p:txBody>
-          <a:bodyPr rtlCol="0" anchor="ctr" lIns="127000"/>
+          <a:bodyPr rtlCol="0" anchor="ctr" lIns="127000">
+            <a:normAutofit/>
+          </a:bodyPr>
           <a:lstStyle/>
           <a:p>
             <a:pPr algn="ctr"/>
@@ -11443,7 +11609,7 @@
         </p:spPr>
         <p:txBody>
           <a:bodyPr wrap="square">
-            <a:spAutoFit/>
+            <a:normAutofit/>
           </a:bodyPr>
           <a:lstStyle/>
           <a:p>
@@ -11500,7 +11666,9 @@
           </a:fontRef>
         </p:style>
         <p:txBody>
-          <a:bodyPr rtlCol="0" anchor="ctr" lIns="127000"/>
+          <a:bodyPr rtlCol="0" anchor="ctr" lIns="127000">
+            <a:normAutofit/>
+          </a:bodyPr>
           <a:lstStyle/>
           <a:p>
             <a:pPr algn="ctr"/>
@@ -11561,7 +11729,9 @@
           </a:fontRef>
         </p:style>
         <p:txBody>
-          <a:bodyPr rtlCol="0" anchor="ctr" lIns="127000"/>
+          <a:bodyPr rtlCol="0" anchor="ctr" lIns="127000">
+            <a:normAutofit/>
+          </a:bodyPr>
           <a:lstStyle/>
           <a:p>
             <a:pPr algn="ctr"/>
@@ -11622,7 +11792,9 @@
           </a:fontRef>
         </p:style>
         <p:txBody>
-          <a:bodyPr rtlCol="0" anchor="ctr" lIns="127000"/>
+          <a:bodyPr rtlCol="0" anchor="ctr" lIns="127000">
+            <a:normAutofit/>
+          </a:bodyPr>
           <a:lstStyle/>
           <a:p>
             <a:pPr algn="ctr"/>
@@ -11683,7 +11855,9 @@
           </a:fontRef>
         </p:style>
         <p:txBody>
-          <a:bodyPr rtlCol="0" anchor="ctr" lIns="127000"/>
+          <a:bodyPr rtlCol="0" anchor="ctr" lIns="127000">
+            <a:normAutofit/>
+          </a:bodyPr>
           <a:lstStyle/>
           <a:p>
             <a:pPr algn="ctr"/>
@@ -11726,7 +11900,7 @@
         </p:spPr>
         <p:txBody>
           <a:bodyPr wrap="square">
-            <a:spAutoFit/>
+            <a:normAutofit/>
           </a:bodyPr>
           <a:lstStyle/>
           <a:p>
@@ -11783,7 +11957,9 @@
           </a:fontRef>
         </p:style>
         <p:txBody>
-          <a:bodyPr rtlCol="0" anchor="ctr" lIns="127000"/>
+          <a:bodyPr rtlCol="0" anchor="ctr" lIns="127000">
+            <a:normAutofit/>
+          </a:bodyPr>
           <a:lstStyle/>
           <a:p>
             <a:pPr algn="ctr"/>
@@ -11844,7 +12020,9 @@
           </a:fontRef>
         </p:style>
         <p:txBody>
-          <a:bodyPr rtlCol="0" anchor="ctr" lIns="127000"/>
+          <a:bodyPr rtlCol="0" anchor="ctr" lIns="127000">
+            <a:normAutofit/>
+          </a:bodyPr>
           <a:lstStyle/>
           <a:p>
             <a:pPr algn="ctr"/>
@@ -11905,7 +12083,9 @@
           </a:fontRef>
         </p:style>
         <p:txBody>
-          <a:bodyPr rtlCol="0" anchor="ctr" lIns="127000"/>
+          <a:bodyPr rtlCol="0" anchor="ctr" lIns="127000">
+            <a:normAutofit/>
+          </a:bodyPr>
           <a:lstStyle/>
           <a:p>
             <a:pPr algn="ctr"/>
@@ -11966,7 +12146,9 @@
           </a:fontRef>
         </p:style>
         <p:txBody>
-          <a:bodyPr rtlCol="0" anchor="ctr" lIns="127000"/>
+          <a:bodyPr rtlCol="0" anchor="ctr" lIns="127000">
+            <a:normAutofit/>
+          </a:bodyPr>
           <a:lstStyle/>
           <a:p>
             <a:pPr algn="ctr"/>
@@ -12009,7 +12191,7 @@
         </p:spPr>
         <p:txBody>
           <a:bodyPr wrap="square">
-            <a:spAutoFit/>
+            <a:normAutofit/>
           </a:bodyPr>
           <a:lstStyle/>
           <a:p>
@@ -12066,7 +12248,9 @@
           </a:fontRef>
         </p:style>
         <p:txBody>
-          <a:bodyPr rtlCol="0" anchor="ctr" lIns="127000"/>
+          <a:bodyPr rtlCol="0" anchor="ctr" lIns="127000">
+            <a:normAutofit/>
+          </a:bodyPr>
           <a:lstStyle/>
           <a:p>
             <a:pPr algn="ctr"/>
@@ -12127,7 +12311,9 @@
           </a:fontRef>
         </p:style>
         <p:txBody>
-          <a:bodyPr rtlCol="0" anchor="ctr" lIns="127000"/>
+          <a:bodyPr rtlCol="0" anchor="ctr" lIns="127000">
+            <a:normAutofit/>
+          </a:bodyPr>
           <a:lstStyle/>
           <a:p>
             <a:pPr algn="ctr"/>
@@ -12188,7 +12374,9 @@
           </a:fontRef>
         </p:style>
         <p:txBody>
-          <a:bodyPr rtlCol="0" anchor="ctr" lIns="127000"/>
+          <a:bodyPr rtlCol="0" anchor="ctr" lIns="127000">
+            <a:normAutofit/>
+          </a:bodyPr>
           <a:lstStyle/>
           <a:p>
             <a:pPr algn="ctr"/>
@@ -12249,7 +12437,9 @@
           </a:fontRef>
         </p:style>
         <p:txBody>
-          <a:bodyPr rtlCol="0" anchor="ctr" lIns="127000"/>
+          <a:bodyPr rtlCol="0" anchor="ctr" lIns="127000">
+            <a:normAutofit/>
+          </a:bodyPr>
           <a:lstStyle/>
           <a:p>
             <a:pPr algn="ctr"/>
@@ -12328,7 +12518,9 @@
           </a:fontRef>
         </p:style>
         <p:txBody>
-          <a:bodyPr rtlCol="0" anchor="ctr"/>
+          <a:bodyPr rtlCol="0" anchor="ctr">
+            <a:normAutofit/>
+          </a:bodyPr>
           <a:lstStyle/>
           <a:p>
             <a:pPr algn="ctr"/>
@@ -12353,7 +12545,7 @@
         </p:spPr>
         <p:txBody>
           <a:bodyPr wrap="square">
-            <a:spAutoFit/>
+            <a:normAutofit/>
           </a:bodyPr>
           <a:lstStyle/>
           <a:p>
@@ -12410,7 +12602,9 @@
           </a:fontRef>
         </p:style>
         <p:txBody>
-          <a:bodyPr rtlCol="0" anchor="ctr"/>
+          <a:bodyPr rtlCol="0" anchor="ctr">
+            <a:normAutofit/>
+          </a:bodyPr>
           <a:lstStyle/>
           <a:p>
             <a:pPr algn="ctr"/>
@@ -12435,7 +12629,7 @@
         </p:spPr>
         <p:txBody>
           <a:bodyPr wrap="square">
-            <a:spAutoFit/>
+            <a:normAutofit/>
           </a:bodyPr>
           <a:lstStyle/>
           <a:p>
@@ -12474,7 +12668,7 @@
         </p:spPr>
         <p:txBody>
           <a:bodyPr wrap="square">
-            <a:spAutoFit/>
+            <a:normAutofit/>
           </a:bodyPr>
           <a:lstStyle/>
           <a:p>
@@ -12531,7 +12725,9 @@
           </a:fontRef>
         </p:style>
         <p:txBody>
-          <a:bodyPr rtlCol="0" anchor="ctr"/>
+          <a:bodyPr rtlCol="0" anchor="ctr">
+            <a:normAutofit/>
+          </a:bodyPr>
           <a:lstStyle/>
           <a:p>
             <a:pPr algn="ctr"/>
@@ -12556,7 +12752,7 @@
         </p:spPr>
         <p:txBody>
           <a:bodyPr wrap="square">
-            <a:spAutoFit/>
+            <a:normAutofit/>
           </a:bodyPr>
           <a:lstStyle/>
           <a:p>
@@ -12595,7 +12791,7 @@
         </p:spPr>
         <p:txBody>
           <a:bodyPr wrap="square">
-            <a:spAutoFit/>
+            <a:normAutofit/>
           </a:bodyPr>
           <a:lstStyle/>
           <a:p>
@@ -12652,7 +12848,9 @@
           </a:fontRef>
         </p:style>
         <p:txBody>
-          <a:bodyPr rtlCol="0" anchor="ctr"/>
+          <a:bodyPr rtlCol="0" anchor="ctr">
+            <a:normAutofit/>
+          </a:bodyPr>
           <a:lstStyle/>
           <a:p>
             <a:pPr algn="ctr"/>
@@ -12677,7 +12875,7 @@
         </p:spPr>
         <p:txBody>
           <a:bodyPr wrap="square">
-            <a:spAutoFit/>
+            <a:normAutofit/>
           </a:bodyPr>
           <a:lstStyle/>
           <a:p>
@@ -12716,7 +12914,7 @@
         </p:spPr>
         <p:txBody>
           <a:bodyPr wrap="square">
-            <a:spAutoFit/>
+            <a:normAutofit/>
           </a:bodyPr>
           <a:lstStyle/>
           <a:p>
@@ -12755,7 +12953,7 @@
         </p:spPr>
         <p:txBody>
           <a:bodyPr wrap="square">
-            <a:spAutoFit/>
+            <a:normAutofit/>
           </a:bodyPr>
           <a:lstStyle/>
           <a:p>
@@ -12794,7 +12992,7 @@
         </p:spPr>
         <p:txBody>
           <a:bodyPr wrap="square">
-            <a:spAutoFit/>
+            <a:normAutofit/>
           </a:bodyPr>
           <a:lstStyle/>
           <a:p>
@@ -12869,7 +13067,9 @@
           </a:fontRef>
         </p:style>
         <p:txBody>
-          <a:bodyPr rtlCol="0" anchor="ctr"/>
+          <a:bodyPr rtlCol="0" anchor="ctr">
+            <a:normAutofit/>
+          </a:bodyPr>
           <a:lstStyle/>
           <a:p>
             <a:pPr algn="ctr"/>
@@ -12894,7 +13094,7 @@
         </p:spPr>
         <p:txBody>
           <a:bodyPr wrap="square">
-            <a:spAutoFit/>
+            <a:normAutofit/>
           </a:bodyPr>
           <a:lstStyle/>
           <a:p>
@@ -12953,7 +13153,9 @@
           </a:fontRef>
         </p:style>
         <p:txBody>
-          <a:bodyPr rtlCol="0" anchor="ctr"/>
+          <a:bodyPr rtlCol="0" anchor="ctr">
+            <a:normAutofit/>
+          </a:bodyPr>
           <a:lstStyle/>
           <a:p>
             <a:pPr algn="ctr"/>
@@ -12996,7 +13198,9 @@
           </a:fontRef>
         </p:style>
         <p:txBody>
-          <a:bodyPr rtlCol="0" anchor="ctr" wrap="square"/>
+          <a:bodyPr rtlCol="0" anchor="ctr" wrap="square">
+            <a:normAutofit/>
+          </a:bodyPr>
           <a:lstStyle/>
           <a:p>
             <a:pPr algn="ctr">
@@ -13034,7 +13238,7 @@
         </p:spPr>
         <p:txBody>
           <a:bodyPr wrap="square">
-            <a:spAutoFit/>
+            <a:normAutofit/>
           </a:bodyPr>
           <a:lstStyle/>
           <a:p>
@@ -13089,7 +13293,7 @@
         </p:spPr>
         <p:txBody>
           <a:bodyPr wrap="square">
-            <a:spAutoFit/>
+            <a:normAutofit/>
           </a:bodyPr>
           <a:lstStyle/>
           <a:p>
@@ -13148,7 +13352,9 @@
           </a:fontRef>
         </p:style>
         <p:txBody>
-          <a:bodyPr rtlCol="0" anchor="ctr"/>
+          <a:bodyPr rtlCol="0" anchor="ctr">
+            <a:normAutofit/>
+          </a:bodyPr>
           <a:lstStyle/>
           <a:p>
             <a:pPr algn="ctr"/>
@@ -13191,7 +13397,9 @@
           </a:fontRef>
         </p:style>
         <p:txBody>
-          <a:bodyPr rtlCol="0" anchor="ctr" wrap="square"/>
+          <a:bodyPr rtlCol="0" anchor="ctr" wrap="square">
+            <a:normAutofit/>
+          </a:bodyPr>
           <a:lstStyle/>
           <a:p>
             <a:pPr algn="ctr">
@@ -13229,7 +13437,7 @@
         </p:spPr>
         <p:txBody>
           <a:bodyPr wrap="square">
-            <a:spAutoFit/>
+            <a:normAutofit/>
           </a:bodyPr>
           <a:lstStyle/>
           <a:p>
@@ -13284,7 +13492,7 @@
         </p:spPr>
         <p:txBody>
           <a:bodyPr wrap="square">
-            <a:spAutoFit/>
+            <a:normAutofit/>
           </a:bodyPr>
           <a:lstStyle/>
           <a:p>
@@ -13343,7 +13551,9 @@
           </a:fontRef>
         </p:style>
         <p:txBody>
-          <a:bodyPr rtlCol="0" anchor="ctr"/>
+          <a:bodyPr rtlCol="0" anchor="ctr">
+            <a:normAutofit/>
+          </a:bodyPr>
           <a:lstStyle/>
           <a:p>
             <a:pPr algn="ctr"/>
@@ -13386,7 +13596,9 @@
           </a:fontRef>
         </p:style>
         <p:txBody>
-          <a:bodyPr rtlCol="0" anchor="ctr" wrap="square"/>
+          <a:bodyPr rtlCol="0" anchor="ctr" wrap="square">
+            <a:normAutofit/>
+          </a:bodyPr>
           <a:lstStyle/>
           <a:p>
             <a:pPr algn="ctr">
@@ -13424,7 +13636,7 @@
         </p:spPr>
         <p:txBody>
           <a:bodyPr wrap="square">
-            <a:spAutoFit/>
+            <a:normAutofit/>
           </a:bodyPr>
           <a:lstStyle/>
           <a:p>
@@ -13479,7 +13691,7 @@
         </p:spPr>
         <p:txBody>
           <a:bodyPr wrap="square">
-            <a:spAutoFit/>
+            <a:normAutofit/>
           </a:bodyPr>
           <a:lstStyle/>
           <a:p>
@@ -13538,7 +13750,9 @@
           </a:fontRef>
         </p:style>
         <p:txBody>
-          <a:bodyPr rtlCol="0" anchor="ctr"/>
+          <a:bodyPr rtlCol="0" anchor="ctr">
+            <a:normAutofit/>
+          </a:bodyPr>
           <a:lstStyle/>
           <a:p>
             <a:pPr algn="ctr"/>
@@ -13581,7 +13795,9 @@
           </a:fontRef>
         </p:style>
         <p:txBody>
-          <a:bodyPr rtlCol="0" anchor="ctr" wrap="square"/>
+          <a:bodyPr rtlCol="0" anchor="ctr" wrap="square">
+            <a:normAutofit/>
+          </a:bodyPr>
           <a:lstStyle/>
           <a:p>
             <a:pPr algn="ctr">
@@ -13619,7 +13835,7 @@
         </p:spPr>
         <p:txBody>
           <a:bodyPr wrap="square">
-            <a:spAutoFit/>
+            <a:normAutofit/>
           </a:bodyPr>
           <a:lstStyle/>
           <a:p>
@@ -13710,7 +13926,9 @@
           </a:fontRef>
         </p:style>
         <p:txBody>
-          <a:bodyPr rtlCol="0" anchor="ctr"/>
+          <a:bodyPr rtlCol="0" anchor="ctr">
+            <a:normAutofit/>
+          </a:bodyPr>
           <a:lstStyle/>
           <a:p>
             <a:pPr algn="ctr"/>
@@ -13735,7 +13953,7 @@
         </p:spPr>
         <p:txBody>
           <a:bodyPr wrap="square">
-            <a:spAutoFit/>
+            <a:normAutofit/>
           </a:bodyPr>
           <a:lstStyle/>
           <a:p>
@@ -13774,7 +13992,7 @@
         </p:spPr>
         <p:txBody>
           <a:bodyPr wrap="square">
-            <a:spAutoFit/>
+            <a:normAutofit/>
           </a:bodyPr>
           <a:lstStyle/>
           <a:p>
@@ -13813,7 +14031,7 @@
         </p:spPr>
         <p:txBody>
           <a:bodyPr wrap="square">
-            <a:spAutoFit/>
+            <a:normAutofit/>
           </a:bodyPr>
           <a:lstStyle/>
           <a:p>
@@ -13870,7 +14088,9 @@
           </a:fontRef>
         </p:style>
         <p:txBody>
-          <a:bodyPr rtlCol="0" anchor="ctr" wrap="square" lIns="177800" tIns="127000" rIns="177800" bIns="127000"/>
+          <a:bodyPr rtlCol="0" anchor="ctr" wrap="square" lIns="177800" tIns="127000" rIns="177800" bIns="127000">
+            <a:normAutofit/>
+          </a:bodyPr>
           <a:lstStyle/>
           <a:p>
             <a:pPr algn="ctr">
@@ -14020,7 +14240,7 @@
         </p:spPr>
         <p:txBody>
           <a:bodyPr wrap="square">
-            <a:spAutoFit/>
+            <a:normAutofit/>
           </a:bodyPr>
           <a:lstStyle/>
           <a:p>
@@ -14079,7 +14299,9 @@
           </a:fontRef>
         </p:style>
         <p:txBody>
-          <a:bodyPr rtlCol="0" anchor="ctr"/>
+          <a:bodyPr rtlCol="0" anchor="ctr">
+            <a:normAutofit/>
+          </a:bodyPr>
           <a:lstStyle/>
           <a:p>
             <a:pPr algn="ctr"/>
@@ -14104,7 +14326,7 @@
         </p:spPr>
         <p:txBody>
           <a:bodyPr wrap="square">
-            <a:spAutoFit/>
+            <a:normAutofit/>
           </a:bodyPr>
           <a:lstStyle/>
           <a:p>
@@ -14163,7 +14385,9 @@
           </a:fontRef>
         </p:style>
         <p:txBody>
-          <a:bodyPr rtlCol="0" anchor="ctr"/>
+          <a:bodyPr rtlCol="0" anchor="ctr">
+            <a:normAutofit/>
+          </a:bodyPr>
           <a:lstStyle/>
           <a:p>
             <a:pPr algn="ctr"/>
@@ -14188,7 +14412,7 @@
         </p:spPr>
         <p:txBody>
           <a:bodyPr wrap="square">
-            <a:spAutoFit/>
+            <a:normAutofit/>
           </a:bodyPr>
           <a:lstStyle/>
           <a:p>
@@ -14247,7 +14471,9 @@
           </a:fontRef>
         </p:style>
         <p:txBody>
-          <a:bodyPr rtlCol="0" anchor="ctr"/>
+          <a:bodyPr rtlCol="0" anchor="ctr">
+            <a:normAutofit/>
+          </a:bodyPr>
           <a:lstStyle/>
           <a:p>
             <a:pPr algn="ctr"/>
@@ -14272,7 +14498,7 @@
         </p:spPr>
         <p:txBody>
           <a:bodyPr wrap="square">
-            <a:spAutoFit/>
+            <a:normAutofit/>
           </a:bodyPr>
           <a:lstStyle/>
           <a:p>
@@ -14331,7 +14557,9 @@
           </a:fontRef>
         </p:style>
         <p:txBody>
-          <a:bodyPr rtlCol="0" anchor="ctr"/>
+          <a:bodyPr rtlCol="0" anchor="ctr">
+            <a:normAutofit/>
+          </a:bodyPr>
           <a:lstStyle/>
           <a:p>
             <a:pPr algn="ctr"/>
@@ -14356,7 +14584,7 @@
         </p:spPr>
         <p:txBody>
           <a:bodyPr wrap="square">
-            <a:spAutoFit/>
+            <a:normAutofit/>
           </a:bodyPr>
           <a:lstStyle/>
           <a:p>
@@ -14415,7 +14643,9 @@
           </a:fontRef>
         </p:style>
         <p:txBody>
-          <a:bodyPr rtlCol="0" anchor="ctr"/>
+          <a:bodyPr rtlCol="0" anchor="ctr">
+            <a:normAutofit/>
+          </a:bodyPr>
           <a:lstStyle/>
           <a:p>
             <a:pPr algn="ctr"/>
@@ -14440,7 +14670,7 @@
         </p:spPr>
         <p:txBody>
           <a:bodyPr wrap="square">
-            <a:spAutoFit/>
+            <a:normAutofit/>
           </a:bodyPr>
           <a:lstStyle/>
           <a:p>
@@ -14499,7 +14729,9 @@
           </a:fontRef>
         </p:style>
         <p:txBody>
-          <a:bodyPr rtlCol="0" anchor="ctr"/>
+          <a:bodyPr rtlCol="0" anchor="ctr">
+            <a:normAutofit/>
+          </a:bodyPr>
           <a:lstStyle/>
           <a:p>
             <a:pPr algn="ctr"/>
@@ -14524,7 +14756,7 @@
         </p:spPr>
         <p:txBody>
           <a:bodyPr wrap="square">
-            <a:spAutoFit/>
+            <a:normAutofit/>
           </a:bodyPr>
           <a:lstStyle/>
           <a:p>
@@ -14599,7 +14831,9 @@
           </a:fontRef>
         </p:style>
         <p:txBody>
-          <a:bodyPr rtlCol="0" anchor="ctr"/>
+          <a:bodyPr rtlCol="0" anchor="ctr">
+            <a:normAutofit/>
+          </a:bodyPr>
           <a:lstStyle/>
           <a:p>
             <a:pPr algn="ctr"/>
@@ -14624,7 +14858,7 @@
         </p:spPr>
         <p:txBody>
           <a:bodyPr wrap="square">
-            <a:spAutoFit/>
+            <a:normAutofit/>
           </a:bodyPr>
           <a:lstStyle/>
           <a:p>
@@ -14663,7 +14897,7 @@
         </p:spPr>
         <p:txBody>
           <a:bodyPr wrap="square">
-            <a:spAutoFit/>
+            <a:normAutofit/>
           </a:bodyPr>
           <a:lstStyle/>
           <a:p>
@@ -14702,7 +14936,7 @@
         </p:spPr>
         <p:txBody>
           <a:bodyPr wrap="square">
-            <a:spAutoFit/>
+            <a:normAutofit/>
           </a:bodyPr>
           <a:lstStyle/>
           <a:p>
@@ -14759,7 +14993,9 @@
           </a:fontRef>
         </p:style>
         <p:txBody>
-          <a:bodyPr rtlCol="0" anchor="ctr" wrap="square" lIns="177800" tIns="127000" rIns="177800" bIns="127000"/>
+          <a:bodyPr rtlCol="0" anchor="ctr" wrap="square" lIns="177800" tIns="127000" rIns="177800" bIns="127000">
+            <a:normAutofit/>
+          </a:bodyPr>
           <a:lstStyle/>
           <a:p>
             <a:pPr algn="ctr">
@@ -14941,7 +15177,7 @@
         </p:spPr>
         <p:txBody>
           <a:bodyPr wrap="square">
-            <a:spAutoFit/>
+            <a:normAutofit/>
           </a:bodyPr>
           <a:lstStyle/>
           <a:p>
@@ -15000,7 +15236,9 @@
           </a:fontRef>
         </p:style>
         <p:txBody>
-          <a:bodyPr rtlCol="0" anchor="ctr"/>
+          <a:bodyPr rtlCol="0" anchor="ctr">
+            <a:normAutofit/>
+          </a:bodyPr>
           <a:lstStyle/>
           <a:p>
             <a:pPr algn="ctr"/>
@@ -15025,7 +15263,7 @@
         </p:spPr>
         <p:txBody>
           <a:bodyPr wrap="square">
-            <a:spAutoFit/>
+            <a:normAutofit/>
           </a:bodyPr>
           <a:lstStyle/>
           <a:p>
@@ -15084,7 +15322,9 @@
           </a:fontRef>
         </p:style>
         <p:txBody>
-          <a:bodyPr rtlCol="0" anchor="ctr"/>
+          <a:bodyPr rtlCol="0" anchor="ctr">
+            <a:normAutofit/>
+          </a:bodyPr>
           <a:lstStyle/>
           <a:p>
             <a:pPr algn="ctr"/>
@@ -15109,7 +15349,7 @@
         </p:spPr>
         <p:txBody>
           <a:bodyPr wrap="square">
-            <a:spAutoFit/>
+            <a:normAutofit/>
           </a:bodyPr>
           <a:lstStyle/>
           <a:p>
@@ -15168,7 +15408,9 @@
           </a:fontRef>
         </p:style>
         <p:txBody>
-          <a:bodyPr rtlCol="0" anchor="ctr"/>
+          <a:bodyPr rtlCol="0" anchor="ctr">
+            <a:normAutofit/>
+          </a:bodyPr>
           <a:lstStyle/>
           <a:p>
             <a:pPr algn="ctr"/>
@@ -15193,7 +15435,7 @@
         </p:spPr>
         <p:txBody>
           <a:bodyPr wrap="square">
-            <a:spAutoFit/>
+            <a:normAutofit/>
           </a:bodyPr>
           <a:lstStyle/>
           <a:p>
@@ -15252,7 +15494,9 @@
           </a:fontRef>
         </p:style>
         <p:txBody>
-          <a:bodyPr rtlCol="0" anchor="ctr"/>
+          <a:bodyPr rtlCol="0" anchor="ctr">
+            <a:normAutofit/>
+          </a:bodyPr>
           <a:lstStyle/>
           <a:p>
             <a:pPr algn="ctr"/>
@@ -15277,7 +15521,7 @@
         </p:spPr>
         <p:txBody>
           <a:bodyPr wrap="square">
-            <a:spAutoFit/>
+            <a:normAutofit/>
           </a:bodyPr>
           <a:lstStyle/>
           <a:p>
@@ -15336,7 +15580,9 @@
           </a:fontRef>
         </p:style>
         <p:txBody>
-          <a:bodyPr rtlCol="0" anchor="ctr"/>
+          <a:bodyPr rtlCol="0" anchor="ctr">
+            <a:normAutofit/>
+          </a:bodyPr>
           <a:lstStyle/>
           <a:p>
             <a:pPr algn="ctr"/>
@@ -15361,7 +15607,7 @@
         </p:spPr>
         <p:txBody>
           <a:bodyPr wrap="square">
-            <a:spAutoFit/>
+            <a:normAutofit/>
           </a:bodyPr>
           <a:lstStyle/>
           <a:p>
@@ -15418,7 +15664,9 @@
           </a:fontRef>
         </p:style>
         <p:txBody>
-          <a:bodyPr rtlCol="0" anchor="ctr" wrap="square" lIns="177800" tIns="127000" rIns="177800" bIns="127000"/>
+          <a:bodyPr rtlCol="0" anchor="ctr" wrap="square" lIns="177800" tIns="127000" rIns="177800" bIns="127000">
+            <a:normAutofit/>
+          </a:bodyPr>
           <a:lstStyle/>
           <a:p>
             <a:pPr algn="ctr">
@@ -15572,7 +15820,9 @@
           </a:fontRef>
         </p:style>
         <p:txBody>
-          <a:bodyPr rtlCol="0" anchor="ctr"/>
+          <a:bodyPr rtlCol="0" anchor="ctr">
+            <a:normAutofit/>
+          </a:bodyPr>
           <a:lstStyle/>
           <a:p>
             <a:pPr algn="ctr"/>
@@ -15597,7 +15847,7 @@
         </p:spPr>
         <p:txBody>
           <a:bodyPr wrap="square">
-            <a:spAutoFit/>
+            <a:normAutofit/>
           </a:bodyPr>
           <a:lstStyle/>
           <a:p>
@@ -15636,7 +15886,7 @@
         </p:spPr>
         <p:txBody>
           <a:bodyPr wrap="square">
-            <a:spAutoFit/>
+            <a:normAutofit/>
           </a:bodyPr>
           <a:lstStyle/>
           <a:p>
@@ -15695,7 +15945,9 @@
           </a:fontRef>
         </p:style>
         <p:txBody>
-          <a:bodyPr rtlCol="0" anchor="ctr"/>
+          <a:bodyPr rtlCol="0" anchor="ctr">
+            <a:normAutofit/>
+          </a:bodyPr>
           <a:lstStyle/>
           <a:p>
             <a:pPr algn="ctr"/>
@@ -15738,7 +15990,9 @@
           </a:fontRef>
         </p:style>
         <p:txBody>
-          <a:bodyPr rtlCol="0" anchor="ctr" wrap="square"/>
+          <a:bodyPr rtlCol="0" anchor="ctr" wrap="square">
+            <a:normAutofit/>
+          </a:bodyPr>
           <a:lstStyle/>
           <a:p>
             <a:pPr algn="ctr">
@@ -15772,7 +16026,7 @@
         </p:spPr>
         <p:txBody>
           <a:bodyPr wrap="square">
-            <a:spAutoFit/>
+            <a:normAutofit/>
           </a:bodyPr>
           <a:lstStyle/>
           <a:p>
@@ -15811,7 +16065,7 @@
         </p:spPr>
         <p:txBody>
           <a:bodyPr wrap="square">
-            <a:spAutoFit/>
+            <a:normAutofit/>
           </a:bodyPr>
           <a:lstStyle/>
           <a:p>
@@ -15884,7 +16138,9 @@
           </a:fontRef>
         </p:style>
         <p:txBody>
-          <a:bodyPr rtlCol="0" anchor="ctr" wrap="square" lIns="177800" tIns="127000" rIns="177800" bIns="127000"/>
+          <a:bodyPr rtlCol="0" anchor="ctr" wrap="square" lIns="177800" tIns="127000" rIns="177800" bIns="127000">
+            <a:normAutofit/>
+          </a:bodyPr>
           <a:lstStyle/>
           <a:p>
             <a:pPr algn="ctr">
@@ -15990,7 +16246,9 @@
           </a:fontRef>
         </p:style>
         <p:txBody>
-          <a:bodyPr rtlCol="0" anchor="ctr"/>
+          <a:bodyPr rtlCol="0" anchor="ctr">
+            <a:normAutofit/>
+          </a:bodyPr>
           <a:lstStyle/>
           <a:p>
             <a:pPr algn="ctr"/>
@@ -16033,7 +16291,9 @@
           </a:fontRef>
         </p:style>
         <p:txBody>
-          <a:bodyPr rtlCol="0" anchor="ctr" wrap="square"/>
+          <a:bodyPr rtlCol="0" anchor="ctr" wrap="square">
+            <a:normAutofit/>
+          </a:bodyPr>
           <a:lstStyle/>
           <a:p>
             <a:pPr algn="ctr">
@@ -16067,7 +16327,7 @@
         </p:spPr>
         <p:txBody>
           <a:bodyPr wrap="square">
-            <a:spAutoFit/>
+            <a:normAutofit/>
           </a:bodyPr>
           <a:lstStyle/>
           <a:p>
@@ -16106,7 +16366,7 @@
         </p:spPr>
         <p:txBody>
           <a:bodyPr wrap="square">
-            <a:spAutoFit/>
+            <a:normAutofit/>
           </a:bodyPr>
           <a:lstStyle/>
           <a:p>
@@ -16179,7 +16439,9 @@
           </a:fontRef>
         </p:style>
         <p:txBody>
-          <a:bodyPr rtlCol="0" anchor="ctr" wrap="square" lIns="177800" tIns="127000" rIns="177800" bIns="127000"/>
+          <a:bodyPr rtlCol="0" anchor="ctr" wrap="square" lIns="177800" tIns="127000" rIns="177800" bIns="127000">
+            <a:normAutofit/>
+          </a:bodyPr>
           <a:lstStyle/>
           <a:p>
             <a:pPr algn="ctr">
@@ -16301,7 +16563,9 @@
           </a:fontRef>
         </p:style>
         <p:txBody>
-          <a:bodyPr rtlCol="0" anchor="ctr"/>
+          <a:bodyPr rtlCol="0" anchor="ctr">
+            <a:normAutofit/>
+          </a:bodyPr>
           <a:lstStyle/>
           <a:p>
             <a:pPr algn="ctr"/>
@@ -16344,7 +16608,9 @@
           </a:fontRef>
         </p:style>
         <p:txBody>
-          <a:bodyPr rtlCol="0" anchor="ctr" wrap="square"/>
+          <a:bodyPr rtlCol="0" anchor="ctr" wrap="square">
+            <a:normAutofit/>
+          </a:bodyPr>
           <a:lstStyle/>
           <a:p>
             <a:pPr algn="ctr">
@@ -16378,7 +16644,7 @@
         </p:spPr>
         <p:txBody>
           <a:bodyPr wrap="square">
-            <a:spAutoFit/>
+            <a:normAutofit/>
           </a:bodyPr>
           <a:lstStyle/>
           <a:p>
@@ -16417,7 +16683,7 @@
         </p:spPr>
         <p:txBody>
           <a:bodyPr wrap="square">
-            <a:spAutoFit/>
+            <a:normAutofit/>
           </a:bodyPr>
           <a:lstStyle/>
           <a:p>
@@ -16490,7 +16756,9 @@
           </a:fontRef>
         </p:style>
         <p:txBody>
-          <a:bodyPr rtlCol="0" anchor="ctr" wrap="square" lIns="177800" tIns="127000" rIns="177800" bIns="127000"/>
+          <a:bodyPr rtlCol="0" anchor="ctr" wrap="square" lIns="177800" tIns="127000" rIns="177800" bIns="127000">
+            <a:normAutofit/>
+          </a:bodyPr>
           <a:lstStyle/>
           <a:p>
             <a:pPr algn="ctr">
@@ -16644,7 +16912,9 @@
           </a:fontRef>
         </p:style>
         <p:txBody>
-          <a:bodyPr rtlCol="0" anchor="ctr"/>
+          <a:bodyPr rtlCol="0" anchor="ctr">
+            <a:normAutofit/>
+          </a:bodyPr>
           <a:lstStyle/>
           <a:p>
             <a:pPr algn="ctr"/>
@@ -16669,7 +16939,7 @@
         </p:spPr>
         <p:txBody>
           <a:bodyPr wrap="square">
-            <a:spAutoFit/>
+            <a:normAutofit/>
           </a:bodyPr>
           <a:lstStyle/>
           <a:p>
@@ -16708,7 +16978,7 @@
         </p:spPr>
         <p:txBody>
           <a:bodyPr wrap="square">
-            <a:spAutoFit/>
+            <a:normAutofit/>
           </a:bodyPr>
           <a:lstStyle/>
           <a:p>
@@ -16747,7 +17017,7 @@
         </p:spPr>
         <p:txBody>
           <a:bodyPr wrap="square">
-            <a:spAutoFit/>
+            <a:normAutofit/>
           </a:bodyPr>
           <a:lstStyle/>
           <a:p>
@@ -16786,7 +17056,7 @@
         </p:spPr>
         <p:txBody>
           <a:bodyPr wrap="square">
-            <a:spAutoFit/>
+            <a:normAutofit/>
           </a:bodyPr>
           <a:lstStyle/>
           <a:p>
@@ -16891,7 +17161,9 @@
           </a:fontRef>
         </p:style>
         <p:txBody>
-          <a:bodyPr rtlCol="0" anchor="ctr" wrap="square" lIns="177800" tIns="127000" rIns="177800" bIns="127000"/>
+          <a:bodyPr rtlCol="0" anchor="ctr" wrap="square" lIns="177800" tIns="127000" rIns="177800" bIns="127000">
+            <a:normAutofit/>
+          </a:bodyPr>
           <a:lstStyle/>
           <a:p>
             <a:pPr algn="ctr">
@@ -17170,7 +17442,9 @@
           </a:fontRef>
         </p:style>
         <p:txBody>
-          <a:bodyPr rtlCol="0" anchor="ctr"/>
+          <a:bodyPr rtlCol="0" anchor="ctr">
+            <a:normAutofit/>
+          </a:bodyPr>
           <a:lstStyle/>
           <a:p>
             <a:pPr algn="ctr"/>
@@ -17195,7 +17469,7 @@
         </p:spPr>
         <p:txBody>
           <a:bodyPr wrap="square">
-            <a:spAutoFit/>
+            <a:normAutofit/>
           </a:bodyPr>
           <a:lstStyle/>
           <a:p>
@@ -17252,7 +17526,9 @@
           </a:fontRef>
         </p:style>
         <p:txBody>
-          <a:bodyPr rtlCol="0" anchor="ctr" wrap="square" lIns="177800" tIns="127000" rIns="177800" bIns="127000"/>
+          <a:bodyPr rtlCol="0" anchor="ctr" wrap="square" lIns="177800" tIns="127000" rIns="177800" bIns="127000">
+            <a:normAutofit/>
+          </a:bodyPr>
           <a:lstStyle/>
           <a:p>
             <a:pPr algn="ctr">
@@ -17634,7 +17910,9 @@
           </a:fontRef>
         </p:style>
         <p:txBody>
-          <a:bodyPr rtlCol="0" anchor="ctr"/>
+          <a:bodyPr rtlCol="0" anchor="ctr">
+            <a:normAutofit/>
+          </a:bodyPr>
           <a:lstStyle/>
           <a:p>
             <a:pPr algn="ctr"/>
@@ -17659,7 +17937,7 @@
         </p:spPr>
         <p:txBody>
           <a:bodyPr wrap="square">
-            <a:spAutoFit/>
+            <a:normAutofit/>
           </a:bodyPr>
           <a:lstStyle/>
           <a:p>
@@ -17698,7 +17976,7 @@
         </p:spPr>
         <p:txBody>
           <a:bodyPr wrap="square">
-            <a:spAutoFit/>
+            <a:normAutofit/>
           </a:bodyPr>
           <a:lstStyle/>
           <a:p>
@@ -17757,7 +18035,9 @@
           </a:fontRef>
         </p:style>
         <p:txBody>
-          <a:bodyPr rtlCol="0" anchor="ctr"/>
+          <a:bodyPr rtlCol="0" anchor="ctr">
+            <a:normAutofit/>
+          </a:bodyPr>
           <a:lstStyle/>
           <a:p>
             <a:pPr algn="ctr"/>
@@ -17800,7 +18080,9 @@
           </a:fontRef>
         </p:style>
         <p:txBody>
-          <a:bodyPr rtlCol="0" anchor="ctr" wrap="square"/>
+          <a:bodyPr rtlCol="0" anchor="ctr" wrap="square">
+            <a:normAutofit/>
+          </a:bodyPr>
           <a:lstStyle/>
           <a:p>
             <a:pPr algn="ctr">
@@ -17834,7 +18116,7 @@
         </p:spPr>
         <p:txBody>
           <a:bodyPr wrap="square">
-            <a:spAutoFit/>
+            <a:normAutofit/>
           </a:bodyPr>
           <a:lstStyle/>
           <a:p>
@@ -17923,7 +18205,9 @@
           </a:fontRef>
         </p:style>
         <p:txBody>
-          <a:bodyPr rtlCol="0" anchor="ctr" wrap="square" lIns="177800" tIns="127000" rIns="177800" bIns="127000"/>
+          <a:bodyPr rtlCol="0" anchor="ctr" wrap="square" lIns="177800" tIns="127000" rIns="177800" bIns="127000">
+            <a:normAutofit/>
+          </a:bodyPr>
           <a:lstStyle/>
           <a:p>
             <a:pPr algn="ctr">
@@ -18167,7 +18451,9 @@
           </a:fontRef>
         </p:style>
         <p:txBody>
-          <a:bodyPr rtlCol="0" anchor="ctr"/>
+          <a:bodyPr rtlCol="0" anchor="ctr">
+            <a:normAutofit/>
+          </a:bodyPr>
           <a:lstStyle/>
           <a:p>
             <a:pPr algn="ctr"/>
@@ -18210,7 +18496,9 @@
           </a:fontRef>
         </p:style>
         <p:txBody>
-          <a:bodyPr rtlCol="0" anchor="ctr" wrap="square"/>
+          <a:bodyPr rtlCol="0" anchor="ctr" wrap="square">
+            <a:normAutofit/>
+          </a:bodyPr>
           <a:lstStyle/>
           <a:p>
             <a:pPr algn="ctr">
@@ -18244,7 +18532,7 @@
         </p:spPr>
         <p:txBody>
           <a:bodyPr wrap="square">
-            <a:spAutoFit/>
+            <a:normAutofit/>
           </a:bodyPr>
           <a:lstStyle/>
           <a:p>
@@ -18333,7 +18621,9 @@
           </a:fontRef>
         </p:style>
         <p:txBody>
-          <a:bodyPr rtlCol="0" anchor="ctr" wrap="square" lIns="177800" tIns="127000" rIns="177800" bIns="127000"/>
+          <a:bodyPr rtlCol="0" anchor="ctr" wrap="square" lIns="177800" tIns="127000" rIns="177800" bIns="127000">
+            <a:normAutofit/>
+          </a:bodyPr>
           <a:lstStyle/>
           <a:p>
             <a:pPr algn="ctr">
@@ -18599,7 +18889,9 @@
           </a:fontRef>
         </p:style>
         <p:txBody>
-          <a:bodyPr rtlCol="0" anchor="ctr"/>
+          <a:bodyPr rtlCol="0" anchor="ctr">
+            <a:normAutofit/>
+          </a:bodyPr>
           <a:lstStyle/>
           <a:p>
             <a:pPr algn="ctr"/>
@@ -18624,7 +18916,7 @@
         </p:spPr>
         <p:txBody>
           <a:bodyPr wrap="square">
-            <a:spAutoFit/>
+            <a:normAutofit/>
           </a:bodyPr>
           <a:lstStyle/>
           <a:p>
@@ -18683,7 +18975,9 @@
           </a:fontRef>
         </p:style>
         <p:txBody>
-          <a:bodyPr rtlCol="0" anchor="ctr"/>
+          <a:bodyPr rtlCol="0" anchor="ctr">
+            <a:normAutofit/>
+          </a:bodyPr>
           <a:lstStyle/>
           <a:p>
             <a:pPr algn="ctr"/>
@@ -18726,7 +19020,9 @@
           </a:fontRef>
         </p:style>
         <p:txBody>
-          <a:bodyPr rtlCol="0" anchor="ctr"/>
+          <a:bodyPr rtlCol="0" anchor="ctr">
+            <a:normAutofit/>
+          </a:bodyPr>
           <a:lstStyle/>
           <a:p>
             <a:pPr algn="ctr"/>
@@ -18751,7 +19047,7 @@
         </p:spPr>
         <p:txBody>
           <a:bodyPr wrap="square">
-            <a:spAutoFit/>
+            <a:normAutofit/>
           </a:bodyPr>
           <a:lstStyle/>
           <a:p>
@@ -18790,7 +19086,7 @@
         </p:spPr>
         <p:txBody>
           <a:bodyPr wrap="square">
-            <a:spAutoFit/>
+            <a:normAutofit/>
           </a:bodyPr>
           <a:lstStyle/>
           <a:p>
@@ -18829,7 +19125,7 @@
         </p:spPr>
         <p:txBody>
           <a:bodyPr wrap="square">
-            <a:spAutoFit/>
+            <a:normAutofit/>
           </a:bodyPr>
           <a:lstStyle/>
           <a:p>
@@ -18888,7 +19184,9 @@
           </a:fontRef>
         </p:style>
         <p:txBody>
-          <a:bodyPr rtlCol="0" anchor="ctr"/>
+          <a:bodyPr rtlCol="0" anchor="ctr">
+            <a:normAutofit/>
+          </a:bodyPr>
           <a:lstStyle/>
           <a:p>
             <a:pPr algn="ctr"/>
@@ -18931,7 +19229,9 @@
           </a:fontRef>
         </p:style>
         <p:txBody>
-          <a:bodyPr rtlCol="0" anchor="ctr"/>
+          <a:bodyPr rtlCol="0" anchor="ctr">
+            <a:normAutofit/>
+          </a:bodyPr>
           <a:lstStyle/>
           <a:p>
             <a:pPr algn="ctr"/>
@@ -18956,7 +19256,7 @@
         </p:spPr>
         <p:txBody>
           <a:bodyPr wrap="square">
-            <a:spAutoFit/>
+            <a:normAutofit/>
           </a:bodyPr>
           <a:lstStyle/>
           <a:p>
@@ -18995,7 +19295,7 @@
         </p:spPr>
         <p:txBody>
           <a:bodyPr wrap="square">
-            <a:spAutoFit/>
+            <a:normAutofit/>
           </a:bodyPr>
           <a:lstStyle/>
           <a:p>
@@ -19034,7 +19334,7 @@
         </p:spPr>
         <p:txBody>
           <a:bodyPr wrap="square">
-            <a:spAutoFit/>
+            <a:normAutofit/>
           </a:bodyPr>
           <a:lstStyle/>
           <a:p>
@@ -19093,7 +19393,9 @@
           </a:fontRef>
         </p:style>
         <p:txBody>
-          <a:bodyPr rtlCol="0" anchor="ctr"/>
+          <a:bodyPr rtlCol="0" anchor="ctr">
+            <a:normAutofit/>
+          </a:bodyPr>
           <a:lstStyle/>
           <a:p>
             <a:pPr algn="ctr"/>
@@ -19136,7 +19438,9 @@
           </a:fontRef>
         </p:style>
         <p:txBody>
-          <a:bodyPr rtlCol="0" anchor="ctr"/>
+          <a:bodyPr rtlCol="0" anchor="ctr">
+            <a:normAutofit/>
+          </a:bodyPr>
           <a:lstStyle/>
           <a:p>
             <a:pPr algn="ctr"/>
@@ -19161,7 +19465,7 @@
         </p:spPr>
         <p:txBody>
           <a:bodyPr wrap="square">
-            <a:spAutoFit/>
+            <a:normAutofit/>
           </a:bodyPr>
           <a:lstStyle/>
           <a:p>
@@ -19200,7 +19504,7 @@
         </p:spPr>
         <p:txBody>
           <a:bodyPr wrap="square">
-            <a:spAutoFit/>
+            <a:normAutofit/>
           </a:bodyPr>
           <a:lstStyle/>
           <a:p>
@@ -19239,7 +19543,7 @@
         </p:spPr>
         <p:txBody>
           <a:bodyPr wrap="square">
-            <a:spAutoFit/>
+            <a:normAutofit/>
           </a:bodyPr>
           <a:lstStyle/>
           <a:p>
@@ -19298,7 +19602,9 @@
           </a:fontRef>
         </p:style>
         <p:txBody>
-          <a:bodyPr rtlCol="0" anchor="ctr"/>
+          <a:bodyPr rtlCol="0" anchor="ctr">
+            <a:normAutofit/>
+          </a:bodyPr>
           <a:lstStyle/>
           <a:p>
             <a:pPr algn="ctr"/>
@@ -19341,7 +19647,9 @@
           </a:fontRef>
         </p:style>
         <p:txBody>
-          <a:bodyPr rtlCol="0" anchor="ctr"/>
+          <a:bodyPr rtlCol="0" anchor="ctr">
+            <a:normAutofit/>
+          </a:bodyPr>
           <a:lstStyle/>
           <a:p>
             <a:pPr algn="ctr"/>
@@ -19366,7 +19674,7 @@
         </p:spPr>
         <p:txBody>
           <a:bodyPr wrap="square">
-            <a:spAutoFit/>
+            <a:normAutofit/>
           </a:bodyPr>
           <a:lstStyle/>
           <a:p>
@@ -19405,7 +19713,7 @@
         </p:spPr>
         <p:txBody>
           <a:bodyPr wrap="square">
-            <a:spAutoFit/>
+            <a:normAutofit/>
           </a:bodyPr>
           <a:lstStyle/>
           <a:p>
@@ -19444,7 +19752,7 @@
         </p:spPr>
         <p:txBody>
           <a:bodyPr wrap="square">
-            <a:spAutoFit/>
+            <a:normAutofit/>
           </a:bodyPr>
           <a:lstStyle/>
           <a:p>
@@ -19519,7 +19827,9 @@
           </a:fontRef>
         </p:style>
         <p:txBody>
-          <a:bodyPr rtlCol="0" anchor="ctr"/>
+          <a:bodyPr rtlCol="0" anchor="ctr">
+            <a:normAutofit/>
+          </a:bodyPr>
           <a:lstStyle/>
           <a:p>
             <a:pPr algn="ctr"/>
@@ -19544,7 +19854,7 @@
         </p:spPr>
         <p:txBody>
           <a:bodyPr wrap="square">
-            <a:spAutoFit/>
+            <a:normAutofit/>
           </a:bodyPr>
           <a:lstStyle/>
           <a:p>
@@ -19583,7 +19893,7 @@
         </p:spPr>
         <p:txBody>
           <a:bodyPr wrap="square">
-            <a:spAutoFit/>
+            <a:normAutofit/>
           </a:bodyPr>
           <a:lstStyle/>
           <a:p>
@@ -19622,7 +19932,7 @@
         </p:spPr>
         <p:txBody>
           <a:bodyPr wrap="square">
-            <a:spAutoFit/>
+            <a:normAutofit/>
           </a:bodyPr>
           <a:lstStyle/>
           <a:p>
@@ -19679,7 +19989,9 @@
           </a:fontRef>
         </p:style>
         <p:txBody>
-          <a:bodyPr rtlCol="0" anchor="ctr"/>
+          <a:bodyPr rtlCol="0" anchor="ctr">
+            <a:normAutofit/>
+          </a:bodyPr>
           <a:lstStyle/>
           <a:p>
             <a:pPr algn="ctr"/>
@@ -19704,7 +20016,7 @@
         </p:spPr>
         <p:txBody>
           <a:bodyPr wrap="square">
-            <a:spAutoFit/>
+            <a:normAutofit/>
           </a:bodyPr>
           <a:lstStyle/>
           <a:p>
@@ -19743,7 +20055,7 @@
         </p:spPr>
         <p:txBody>
           <a:bodyPr wrap="square">
-            <a:spAutoFit/>
+            <a:normAutofit/>
           </a:bodyPr>
           <a:lstStyle/>
           <a:p>
@@ -19800,7 +20112,9 @@
           </a:fontRef>
         </p:style>
         <p:txBody>
-          <a:bodyPr rtlCol="0" anchor="ctr"/>
+          <a:bodyPr rtlCol="0" anchor="ctr">
+            <a:normAutofit/>
+          </a:bodyPr>
           <a:lstStyle/>
           <a:p>
             <a:pPr algn="ctr"/>
@@ -19825,7 +20139,7 @@
         </p:spPr>
         <p:txBody>
           <a:bodyPr wrap="square">
-            <a:spAutoFit/>
+            <a:normAutofit/>
           </a:bodyPr>
           <a:lstStyle/>
           <a:p>
@@ -19864,7 +20178,7 @@
         </p:spPr>
         <p:txBody>
           <a:bodyPr wrap="square">
-            <a:spAutoFit/>
+            <a:normAutofit/>
           </a:bodyPr>
           <a:lstStyle/>
           <a:p>
@@ -19921,7 +20235,9 @@
           </a:fontRef>
         </p:style>
         <p:txBody>
-          <a:bodyPr rtlCol="0" anchor="ctr"/>
+          <a:bodyPr rtlCol="0" anchor="ctr">
+            <a:normAutofit/>
+          </a:bodyPr>
           <a:lstStyle/>
           <a:p>
             <a:pPr algn="ctr"/>
@@ -19946,7 +20262,7 @@
         </p:spPr>
         <p:txBody>
           <a:bodyPr wrap="square">
-            <a:spAutoFit/>
+            <a:normAutofit/>
           </a:bodyPr>
           <a:lstStyle/>
           <a:p>
@@ -19985,7 +20301,7 @@
         </p:spPr>
         <p:txBody>
           <a:bodyPr wrap="square">
-            <a:spAutoFit/>
+            <a:normAutofit/>
           </a:bodyPr>
           <a:lstStyle/>
           <a:p>
@@ -20042,7 +20358,9 @@
           </a:fontRef>
         </p:style>
         <p:txBody>
-          <a:bodyPr rtlCol="0" anchor="ctr"/>
+          <a:bodyPr rtlCol="0" anchor="ctr">
+            <a:normAutofit/>
+          </a:bodyPr>
           <a:lstStyle/>
           <a:p>
             <a:pPr algn="ctr"/>
@@ -20067,7 +20385,7 @@
         </p:spPr>
         <p:txBody>
           <a:bodyPr wrap="square">
-            <a:spAutoFit/>
+            <a:normAutofit/>
           </a:bodyPr>
           <a:lstStyle/>
           <a:p>
@@ -20106,7 +20424,7 @@
         </p:spPr>
         <p:txBody>
           <a:bodyPr wrap="square">
-            <a:spAutoFit/>
+            <a:normAutofit/>
           </a:bodyPr>
           <a:lstStyle/>
           <a:p>
@@ -20145,7 +20463,7 @@
         </p:spPr>
         <p:txBody>
           <a:bodyPr wrap="square">
-            <a:spAutoFit/>
+            <a:normAutofit/>
           </a:bodyPr>
           <a:lstStyle/>
           <a:p>
@@ -20202,7 +20520,9 @@
           </a:fontRef>
         </p:style>
         <p:txBody>
-          <a:bodyPr rtlCol="0" anchor="ctr" wrap="square" lIns="177800" tIns="127000" rIns="177800" bIns="127000"/>
+          <a:bodyPr rtlCol="0" anchor="ctr" wrap="square" lIns="177800" tIns="127000" rIns="177800" bIns="127000">
+            <a:normAutofit/>
+          </a:bodyPr>
           <a:lstStyle/>
           <a:p>
             <a:pPr algn="ctr">
@@ -20349,7 +20669,7 @@
         </p:spPr>
         <p:txBody>
           <a:bodyPr wrap="square">
-            <a:spAutoFit/>
+            <a:normAutofit/>
           </a:bodyPr>
           <a:lstStyle/>
           <a:p>
@@ -20406,7 +20726,9 @@
           </a:fontRef>
         </p:style>
         <p:txBody>
-          <a:bodyPr rtlCol="0" anchor="ctr" wrap="square" lIns="177800" tIns="127000" rIns="177800" bIns="127000"/>
+          <a:bodyPr rtlCol="0" anchor="ctr" wrap="square" lIns="177800" tIns="127000" rIns="177800" bIns="127000">
+            <a:normAutofit/>
+          </a:bodyPr>
           <a:lstStyle/>
           <a:p>
             <a:pPr algn="ctr">

</xml_diff>